<commit_message>
Challenge III: angepasste Praesentation uebernommen (Bewertungsbogen-Folie ist jetzt Agenda)
Co-Authored-By: Claude Sonnet 5.5 <noreply@anthropic.com>
Claude-Session: https://claude.ai/code/session_01R5hcuhxU27rhcGhdznt7WV
</commit_message>
<xml_diff>
--- a/Challenge-III-Ice-Truck-Cloud/Praesentation/ice-truck-in-der-cloud.pptx
+++ b/Challenge-III-Ice-Truck-Cloud/Praesentation/ice-truck-in-der-cloud.pptx
@@ -1571,7 +1571,7 @@
           </a:prstGeom>
           <a:extLst>
             <a:ext uri="{C572A759-6A51-4108-AA02-DFA0A04FC94B}">
-              <ma14:wrappingTextBoxFlag xmlns:ma14="http://schemas.microsoft.com/office/mac/drawingml/2011/main" xmlns="" val="0"/>
+              <ma14:wrappingTextBoxFlag xmlns="" xmlns:ma14="http://schemas.microsoft.com/office/mac/drawingml/2011/main" val="0"/>
             </a:ext>
           </a:extLst>
         </p:spPr>
@@ -1735,7 +1735,7 @@
           </a:prstGeom>
           <a:extLst>
             <a:ext uri="{C572A759-6A51-4108-AA02-DFA0A04FC94B}">
-              <ma14:wrappingTextBoxFlag xmlns:ma14="http://schemas.microsoft.com/office/mac/drawingml/2011/main" xmlns="" val="0"/>
+              <ma14:wrappingTextBoxFlag xmlns="" xmlns:ma14="http://schemas.microsoft.com/office/mac/drawingml/2011/main" val="0"/>
             </a:ext>
           </a:extLst>
         </p:spPr>
@@ -1899,7 +1899,7 @@
           </a:prstGeom>
           <a:extLst>
             <a:ext uri="{C572A759-6A51-4108-AA02-DFA0A04FC94B}">
-              <ma14:wrappingTextBoxFlag xmlns:ma14="http://schemas.microsoft.com/office/mac/drawingml/2011/main" xmlns="" val="0"/>
+              <ma14:wrappingTextBoxFlag xmlns="" xmlns:ma14="http://schemas.microsoft.com/office/mac/drawingml/2011/main" val="0"/>
             </a:ext>
           </a:extLst>
         </p:spPr>
@@ -2063,7 +2063,7 @@
           </a:prstGeom>
           <a:extLst>
             <a:ext uri="{C572A759-6A51-4108-AA02-DFA0A04FC94B}">
-              <ma14:wrappingTextBoxFlag xmlns:ma14="http://schemas.microsoft.com/office/mac/drawingml/2011/main" xmlns="" val="0"/>
+              <ma14:wrappingTextBoxFlag xmlns="" xmlns:ma14="http://schemas.microsoft.com/office/mac/drawingml/2011/main" val="0"/>
             </a:ext>
           </a:extLst>
         </p:spPr>
@@ -2141,7 +2141,7 @@
           </a:prstGeom>
           <a:extLst>
             <a:ext uri="{C572A759-6A51-4108-AA02-DFA0A04FC94B}">
-              <ma14:wrappingTextBoxFlag xmlns:ma14="http://schemas.microsoft.com/office/mac/drawingml/2011/main" xmlns="" val="0"/>
+              <ma14:wrappingTextBoxFlag xmlns="" xmlns:ma14="http://schemas.microsoft.com/office/mac/drawingml/2011/main" val="0"/>
             </a:ext>
           </a:extLst>
         </p:spPr>
@@ -2665,88 +2665,6 @@
       </p:sp>
       <p:sp>
         <p:nvSpPr>
-          <p:cNvPr id="8" name="Status"/>
-          <p:cNvSpPr/>
-          <p:nvPr/>
-        </p:nvSpPr>
-        <p:spPr>
-          <a:xfrm>
-            <a:off x="640080" y="4572000"/>
-            <a:ext cx="1554480" cy="310896"/>
-          </a:xfrm>
-          <a:prstGeom prst="roundRect">
-            <a:avLst>
-              <a:gd name="adj" fmla="val 50000"/>
-            </a:avLst>
-          </a:prstGeom>
-          <a:solidFill>
-            <a:srgbClr val="6CCBF5"/>
-          </a:solidFill>
-          <a:ln/>
-        </p:spPr>
-        <p:txBody>
-          <a:bodyPr wrap="square" lIns="0" tIns="0" rIns="0" bIns="0" rtlCol="0" anchor="ctr"/>
-          <a:lstStyle/>
-          <a:p>
-            <a:pPr marL="0" indent="0" algn="ctr">
-              <a:buNone/>
-            </a:pPr>
-            <a:r>
-              <a:rPr lang="en-US" sz="1200" b="1" dirty="0">
-                <a:solidFill>
-                  <a:srgbClr val="0E1B2C"/>
-                </a:solidFill>
-                <a:latin typeface="Calibri" pitchFamily="34" charset="0"/>
-                <a:ea typeface="Calibri" pitchFamily="34" charset="-122"/>
-                <a:cs typeface="Calibri" pitchFamily="34" charset="-120"/>
-              </a:rPr>
-              <a:t>Team 13-1</a:t>
-            </a:r>
-            <a:endParaRPr lang="en-US" sz="1200" dirty="0"/>
-          </a:p>
-        </p:txBody>
-      </p:sp>
-      <p:sp>
-        <p:nvSpPr>
-          <p:cNvPr id="9" name="Text 6"/>
-          <p:cNvSpPr txBox="1"/>
-          <p:nvPr/>
-        </p:nvSpPr>
-        <p:spPr>
-          <a:xfrm>
-            <a:off x="2377440" y="4617720"/>
-            <a:ext cx="3657600" cy="274320"/>
-          </a:xfrm>
-          <a:prstGeom prst="rect">
-            <a:avLst/>
-          </a:prstGeom>
-          <a:noFill/>
-          <a:ln/>
-        </p:spPr>
-        <p:txBody>
-          <a:bodyPr wrap="square" lIns="0" tIns="0" rIns="0" bIns="0" rtlCol="0" anchor="t"/>
-          <a:lstStyle/>
-          <a:p>
-            <a:pPr marL="0" indent="0">
-              <a:buNone/>
-            </a:pPr>
-            <a:r>
-              <a:rPr lang="en-US" sz="1600" dirty="0">
-                <a:solidFill>
-                  <a:srgbClr val="B8C7D9"/>
-                </a:solidFill>
-                <a:latin typeface="Calibri" pitchFamily="34" charset="0"/>
-                <a:ea typeface="Calibri" pitchFamily="34" charset="-122"/>
-                <a:cs typeface="Calibri" pitchFamily="34" charset="-120"/>
-              </a:rPr>
-              <a:t>Smart Systems · BH4ab</a:t>
-            </a:r>
-            <a:endParaRPr lang="en-US" sz="1600" dirty="0"/>
-          </a:p>
-        </p:txBody>
-      </p:sp>
-      <p:sp>
-        <p:nvSpPr>
           <p:cNvPr id="25" name="Slide Number Placeholder 0"/>
           <p:cNvSpPr>
             <a:spLocks noGrp="1"/>
@@ -2765,7 +2683,7 @@
           </a:prstGeom>
           <a:extLst>
             <a:ext uri="{C572A759-6A51-4108-AA02-DFA0A04FC94B}">
-              <ma14:wrappingTextBoxFlag xmlns:ma14="http://schemas.microsoft.com/office/mac/drawingml/2011/main" xmlns="" val="0"/>
+              <ma14:wrappingTextBoxFlag xmlns="" xmlns:ma14="http://schemas.microsoft.com/office/mac/drawingml/2011/main" val="0"/>
             </a:ext>
           </a:extLst>
         </p:spPr>
@@ -2793,6 +2711,36 @@
           </a:p>
         </p:txBody>
       </p:sp>
+      <p:pic>
+        <p:nvPicPr>
+          <p:cNvPr id="17" name="Grafik 16">
+            <a:extLst>
+              <a:ext uri="{FF2B5EF4-FFF2-40B4-BE49-F238E27FC236}">
+                <a16:creationId xmlns:a16="http://schemas.microsoft.com/office/drawing/2014/main" id="{73DCD6A8-57E4-9A15-0494-553FF6B0660D}"/>
+              </a:ext>
+            </a:extLst>
+          </p:cNvPr>
+          <p:cNvPicPr>
+            <a:picLocks noChangeAspect="1"/>
+          </p:cNvPicPr>
+          <p:nvPr/>
+        </p:nvPicPr>
+        <p:blipFill>
+          <a:blip r:embed="rId4"/>
+          <a:stretch>
+            <a:fillRect/>
+          </a:stretch>
+        </p:blipFill>
+        <p:spPr>
+          <a:xfrm>
+            <a:off x="244021" y="6051550"/>
+            <a:ext cx="4470400" cy="698500"/>
+          </a:xfrm>
+          <a:prstGeom prst="rect">
+            <a:avLst/>
+          </a:prstGeom>
+        </p:spPr>
+      </p:pic>
     </p:spTree>
   </p:cSld>
   <p:clrMapOvr>
@@ -2859,49 +2807,6 @@
       </p:sp>
       <p:sp>
         <p:nvSpPr>
-          <p:cNvPr id="3" name="Punkte"/>
-          <p:cNvSpPr/>
-          <p:nvPr/>
-        </p:nvSpPr>
-        <p:spPr>
-          <a:xfrm>
-            <a:off x="9994392" y="457200"/>
-            <a:ext cx="1554480" cy="457200"/>
-          </a:xfrm>
-          <a:prstGeom prst="roundRect">
-            <a:avLst>
-              <a:gd name="adj" fmla="val 50000"/>
-            </a:avLst>
-          </a:prstGeom>
-          <a:solidFill>
-            <a:schemeClr val="accent2"/>
-          </a:solidFill>
-          <a:ln/>
-        </p:spPr>
-        <p:txBody>
-          <a:bodyPr wrap="square" lIns="0" tIns="0" rIns="0" bIns="0" rtlCol="0" anchor="ctr"/>
-          <a:lstStyle/>
-          <a:p>
-            <a:pPr marL="0" indent="0" algn="ctr">
-              <a:buNone/>
-            </a:pPr>
-            <a:r>
-              <a:rPr lang="en-US" sz="1600" b="1" dirty="0">
-                <a:solidFill>
-                  <a:schemeClr val="tx1"/>
-                </a:solidFill>
-                <a:latin typeface="Calibri" pitchFamily="34" charset="0"/>
-                <a:ea typeface="Calibri" pitchFamily="34" charset="-122"/>
-                <a:cs typeface="Calibri" pitchFamily="34" charset="-120"/>
-              </a:rPr>
-              <a:t>10 Punkte</a:t>
-            </a:r>
-            <a:endParaRPr lang="en-US" sz="1600" dirty="0"/>
-          </a:p>
-        </p:txBody>
-      </p:sp>
-      <p:sp>
-        <p:nvSpPr>
           <p:cNvPr id="4" name="Kriterium"/>
           <p:cNvSpPr txBox="1"/>
           <p:nvPr/>
@@ -3384,7 +3289,29 @@
                 <a:ea typeface="Calibri" pitchFamily="34" charset="-122"/>
                 <a:cs typeface="Calibri" pitchFamily="34" charset="-120"/>
               </a:rPr>
-              <a:t>Keys in .env (chmod 600), nie im Git-Repository</a:t>
+              <a:t>Keys in .env (</a:t>
+            </a:r>
+            <a:r>
+              <a:rPr lang="en-US" sz="1400" dirty="0" err="1">
+                <a:solidFill>
+                  <a:srgbClr val="B8C7D9"/>
+                </a:solidFill>
+                <a:latin typeface="Calibri" pitchFamily="34" charset="0"/>
+                <a:ea typeface="Calibri" pitchFamily="34" charset="-122"/>
+                <a:cs typeface="Calibri" pitchFamily="34" charset="-120"/>
+              </a:rPr>
+              <a:t>chmod</a:t>
+            </a:r>
+            <a:r>
+              <a:rPr lang="en-US" sz="1400" dirty="0">
+                <a:solidFill>
+                  <a:srgbClr val="B8C7D9"/>
+                </a:solidFill>
+                <a:latin typeface="Calibri" pitchFamily="34" charset="0"/>
+                <a:ea typeface="Calibri" pitchFamily="34" charset="-122"/>
+                <a:cs typeface="Calibri" pitchFamily="34" charset="-120"/>
+              </a:rPr>
+              <a:t> 600</a:t>
             </a:r>
             <a:endParaRPr lang="en-US" sz="1400" dirty="0"/>
           </a:p>
@@ -3800,56 +3727,6 @@
       </p:sp>
       <p:sp>
         <p:nvSpPr>
-          <p:cNvPr id="30" name="Text 22"/>
-          <p:cNvSpPr txBox="1"/>
-          <p:nvPr/>
-        </p:nvSpPr>
-        <p:spPr>
-          <a:xfrm>
-            <a:off x="640080" y="5623560"/>
-            <a:ext cx="10908792" cy="457200"/>
-          </a:xfrm>
-          <a:prstGeom prst="rect">
-            <a:avLst/>
-          </a:prstGeom>
-          <a:noFill/>
-          <a:ln/>
-        </p:spPr>
-        <p:txBody>
-          <a:bodyPr wrap="square" lIns="0" tIns="0" rIns="0" bIns="0" rtlCol="0" anchor="t"/>
-          <a:lstStyle/>
-          <a:p>
-            <a:pPr marL="0" indent="0">
-              <a:buNone/>
-            </a:pPr>
-            <a:r>
-              <a:rPr lang="en-US" sz="1600" b="1" dirty="0">
-                <a:solidFill>
-                  <a:srgbClr val="F59E42"/>
-                </a:solidFill>
-                <a:latin typeface="Calibri" pitchFamily="34" charset="0"/>
-                <a:ea typeface="Calibri" pitchFamily="34" charset="-122"/>
-                <a:cs typeface="Calibri" pitchFamily="34" charset="-120"/>
-              </a:rPr>
-              <a:t>Grenzen: </a:t>
-            </a:r>
-            <a:r>
-              <a:rPr lang="en-US" sz="1600" dirty="0">
-                <a:solidFill>
-                  <a:srgbClr val="F59E42"/>
-                </a:solidFill>
-                <a:latin typeface="Calibri" pitchFamily="34" charset="0"/>
-                <a:ea typeface="Calibri" pitchFamily="34" charset="-122"/>
-                <a:cs typeface="Calibri" pitchFamily="34" charset="-120"/>
-              </a:rPr>
-              <a:t>Pi-Terminal (ttyd) ohne Anmeldung · Uhr ohne Batterie · Free-Tarif ohne Löschschutz</a:t>
-            </a:r>
-            <a:endParaRPr lang="en-US" sz="1600" dirty="0"/>
-          </a:p>
-        </p:txBody>
-      </p:sp>
-      <p:sp>
-        <p:nvSpPr>
           <p:cNvPr id="31" name="Slide Number Placeholder 0"/>
           <p:cNvSpPr>
             <a:spLocks noGrp="1"/>
@@ -3868,7 +3745,7 @@
           </a:prstGeom>
           <a:extLst>
             <a:ext uri="{C572A759-6A51-4108-AA02-DFA0A04FC94B}">
-              <ma14:wrappingTextBoxFlag xmlns:ma14="http://schemas.microsoft.com/office/mac/drawingml/2011/main" xmlns="" val="0"/>
+              <ma14:wrappingTextBoxFlag xmlns="" xmlns:ma14="http://schemas.microsoft.com/office/mac/drawingml/2011/main" val="0"/>
             </a:ext>
           </a:extLst>
         </p:spPr>
@@ -3896,6 +3773,36 @@
           </a:p>
         </p:txBody>
       </p:sp>
+      <p:pic>
+        <p:nvPicPr>
+          <p:cNvPr id="32" name="Grafik 31">
+            <a:extLst>
+              <a:ext uri="{FF2B5EF4-FFF2-40B4-BE49-F238E27FC236}">
+                <a16:creationId xmlns:a16="http://schemas.microsoft.com/office/drawing/2014/main" id="{923291AF-D9C2-50B0-09B1-E461E5B04E85}"/>
+              </a:ext>
+            </a:extLst>
+          </p:cNvPr>
+          <p:cNvPicPr>
+            <a:picLocks noChangeAspect="1"/>
+          </p:cNvPicPr>
+          <p:nvPr/>
+        </p:nvPicPr>
+        <p:blipFill>
+          <a:blip r:embed="rId9"/>
+          <a:stretch>
+            <a:fillRect/>
+          </a:stretch>
+        </p:blipFill>
+        <p:spPr>
+          <a:xfrm>
+            <a:off x="244021" y="6051550"/>
+            <a:ext cx="4470400" cy="698500"/>
+          </a:xfrm>
+          <a:prstGeom prst="rect">
+            <a:avLst/>
+          </a:prstGeom>
+        </p:spPr>
+      </p:pic>
     </p:spTree>
   </p:cSld>
   <p:clrMapOvr>
@@ -3962,49 +3869,6 @@
       </p:sp>
       <p:sp>
         <p:nvSpPr>
-          <p:cNvPr id="3" name="Punkte"/>
-          <p:cNvSpPr/>
-          <p:nvPr/>
-        </p:nvSpPr>
-        <p:spPr>
-          <a:xfrm>
-            <a:off x="9994392" y="457200"/>
-            <a:ext cx="1554480" cy="457200"/>
-          </a:xfrm>
-          <a:prstGeom prst="roundRect">
-            <a:avLst>
-              <a:gd name="adj" fmla="val 50000"/>
-            </a:avLst>
-          </a:prstGeom>
-          <a:solidFill>
-            <a:schemeClr val="accent1"/>
-          </a:solidFill>
-          <a:ln/>
-        </p:spPr>
-        <p:txBody>
-          <a:bodyPr wrap="square" lIns="0" tIns="0" rIns="0" bIns="0" rtlCol="0" anchor="ctr"/>
-          <a:lstStyle/>
-          <a:p>
-            <a:pPr marL="0" indent="0" algn="ctr">
-              <a:buNone/>
-            </a:pPr>
-            <a:r>
-              <a:rPr lang="en-US" sz="1600" b="1" dirty="0">
-                <a:solidFill>
-                  <a:srgbClr val="FFFFFF"/>
-                </a:solidFill>
-                <a:latin typeface="Calibri" pitchFamily="34" charset="0"/>
-                <a:ea typeface="Calibri" pitchFamily="34" charset="-122"/>
-                <a:cs typeface="Calibri" pitchFamily="34" charset="-120"/>
-              </a:rPr>
-              <a:t>10 Punkte</a:t>
-            </a:r>
-            <a:endParaRPr lang="en-US" sz="1600" dirty="0"/>
-          </a:p>
-        </p:txBody>
-      </p:sp>
-      <p:sp>
-        <p:nvSpPr>
           <p:cNvPr id="4" name="Kriterium"/>
           <p:cNvSpPr txBox="1"/>
           <p:nvPr/>
@@ -4621,7 +4485,7 @@
           </a:prstGeom>
           <a:extLst>
             <a:ext uri="{C572A759-6A51-4108-AA02-DFA0A04FC94B}">
-              <ma14:wrappingTextBoxFlag xmlns:ma14="http://schemas.microsoft.com/office/mac/drawingml/2011/main" xmlns="" val="0"/>
+              <ma14:wrappingTextBoxFlag xmlns="" xmlns:ma14="http://schemas.microsoft.com/office/mac/drawingml/2011/main" val="0"/>
             </a:ext>
           </a:extLst>
         </p:spPr>
@@ -4651,10 +4515,10 @@
       </p:sp>
       <p:pic>
         <p:nvPicPr>
-          <p:cNvPr id="23" name="Grafik 22">
+          <p:cNvPr id="22" name="Grafik 21">
             <a:extLst>
               <a:ext uri="{FF2B5EF4-FFF2-40B4-BE49-F238E27FC236}">
-                <a16:creationId xmlns:a16="http://schemas.microsoft.com/office/drawing/2014/main" id="{E69BF621-445A-D77F-15E2-6B5830110610}"/>
+                <a16:creationId xmlns:a16="http://schemas.microsoft.com/office/drawing/2014/main" id="{CB3672A6-F0C4-FED0-51C7-8CB747818631}"/>
               </a:ext>
             </a:extLst>
           </p:cNvPr>
@@ -4671,8 +4535,38 @@
         </p:blipFill>
         <p:spPr>
           <a:xfrm>
-            <a:off x="640080" y="1783080"/>
-            <a:ext cx="6766559" cy="4233337"/>
+            <a:off x="406401" y="6016417"/>
+            <a:ext cx="4470400" cy="698500"/>
+          </a:xfrm>
+          <a:prstGeom prst="rect">
+            <a:avLst/>
+          </a:prstGeom>
+        </p:spPr>
+      </p:pic>
+      <p:pic>
+        <p:nvPicPr>
+          <p:cNvPr id="26" name="Grafik 25">
+            <a:extLst>
+              <a:ext uri="{FF2B5EF4-FFF2-40B4-BE49-F238E27FC236}">
+                <a16:creationId xmlns:a16="http://schemas.microsoft.com/office/drawing/2014/main" id="{EDC45D07-905A-C930-18C1-735ABEB56AAC}"/>
+              </a:ext>
+            </a:extLst>
+          </p:cNvPr>
+          <p:cNvPicPr>
+            <a:picLocks noChangeAspect="1"/>
+          </p:cNvPicPr>
+          <p:nvPr/>
+        </p:nvPicPr>
+        <p:blipFill>
+          <a:blip r:embed="rId9"/>
+          <a:stretch>
+            <a:fillRect/>
+          </a:stretch>
+        </p:blipFill>
+        <p:spPr>
+          <a:xfrm>
+            <a:off x="560678" y="1543050"/>
+            <a:ext cx="6925364" cy="4723417"/>
           </a:xfrm>
           <a:prstGeom prst="rect">
             <a:avLst/>
@@ -4745,49 +4639,6 @@
       </p:sp>
       <p:sp>
         <p:nvSpPr>
-          <p:cNvPr id="3" name="Punkte"/>
-          <p:cNvSpPr/>
-          <p:nvPr/>
-        </p:nvSpPr>
-        <p:spPr>
-          <a:xfrm>
-            <a:off x="9994392" y="457200"/>
-            <a:ext cx="1554480" cy="457200"/>
-          </a:xfrm>
-          <a:prstGeom prst="roundRect">
-            <a:avLst>
-              <a:gd name="adj" fmla="val 50000"/>
-            </a:avLst>
-          </a:prstGeom>
-          <a:solidFill>
-            <a:schemeClr val="accent1"/>
-          </a:solidFill>
-          <a:ln/>
-        </p:spPr>
-        <p:txBody>
-          <a:bodyPr wrap="square" lIns="0" tIns="0" rIns="0" bIns="0" rtlCol="0" anchor="ctr"/>
-          <a:lstStyle/>
-          <a:p>
-            <a:pPr marL="0" indent="0" algn="ctr">
-              <a:buNone/>
-            </a:pPr>
-            <a:r>
-              <a:rPr lang="en-US" sz="1600" b="1" dirty="0">
-                <a:solidFill>
-                  <a:srgbClr val="FFFFFF"/>
-                </a:solidFill>
-                <a:latin typeface="Calibri" pitchFamily="34" charset="0"/>
-                <a:ea typeface="Calibri" pitchFamily="34" charset="-122"/>
-                <a:cs typeface="Calibri" pitchFamily="34" charset="-120"/>
-              </a:rPr>
-              <a:t>5 Punkte</a:t>
-            </a:r>
-            <a:endParaRPr lang="en-US" sz="1600" dirty="0"/>
-          </a:p>
-        </p:txBody>
-      </p:sp>
-      <p:sp>
-        <p:nvSpPr>
           <p:cNvPr id="4" name="Kriterium"/>
           <p:cNvSpPr txBox="1"/>
           <p:nvPr/>
@@ -5508,7 +5359,7 @@
           </a:prstGeom>
           <a:extLst>
             <a:ext uri="{C572A759-6A51-4108-AA02-DFA0A04FC94B}">
-              <ma14:wrappingTextBoxFlag xmlns:ma14="http://schemas.microsoft.com/office/mac/drawingml/2011/main" xmlns="" val="0"/>
+              <ma14:wrappingTextBoxFlag xmlns="" xmlns:ma14="http://schemas.microsoft.com/office/mac/drawingml/2011/main" val="0"/>
             </a:ext>
           </a:extLst>
         </p:spPr>
@@ -5536,6 +5387,36 @@
           </a:p>
         </p:txBody>
       </p:sp>
+      <p:pic>
+        <p:nvPicPr>
+          <p:cNvPr id="22" name="Grafik 21">
+            <a:extLst>
+              <a:ext uri="{FF2B5EF4-FFF2-40B4-BE49-F238E27FC236}">
+                <a16:creationId xmlns:a16="http://schemas.microsoft.com/office/drawing/2014/main" id="{EE776B42-F0FD-0F34-5B65-075F17A17786}"/>
+              </a:ext>
+            </a:extLst>
+          </p:cNvPr>
+          <p:cNvPicPr>
+            <a:picLocks noChangeAspect="1"/>
+          </p:cNvPicPr>
+          <p:nvPr/>
+        </p:nvPicPr>
+        <p:blipFill>
+          <a:blip r:embed="rId3"/>
+          <a:stretch>
+            <a:fillRect/>
+          </a:stretch>
+        </p:blipFill>
+        <p:spPr>
+          <a:xfrm>
+            <a:off x="480786" y="6051550"/>
+            <a:ext cx="4470400" cy="698500"/>
+          </a:xfrm>
+          <a:prstGeom prst="rect">
+            <a:avLst/>
+          </a:prstGeom>
+        </p:spPr>
+      </p:pic>
     </p:spTree>
   </p:cSld>
   <p:clrMapOvr>
@@ -6084,7 +5965,7 @@
                 <a:ea typeface="Calibri" pitchFamily="34" charset="-122"/>
                 <a:cs typeface="Calibri" pitchFamily="34" charset="-120"/>
               </a:rPr>
-              <a:t>Danke – Fragen?</a:t>
+              <a:t>Danke!</a:t>
             </a:r>
             <a:endParaRPr lang="en-US" sz="3600" dirty="0"/>
           </a:p>
@@ -6110,7 +5991,7 @@
           </a:prstGeom>
           <a:extLst>
             <a:ext uri="{C572A759-6A51-4108-AA02-DFA0A04FC94B}">
-              <ma14:wrappingTextBoxFlag xmlns:ma14="http://schemas.microsoft.com/office/mac/drawingml/2011/main" xmlns="" val="0"/>
+              <ma14:wrappingTextBoxFlag xmlns="" xmlns:ma14="http://schemas.microsoft.com/office/mac/drawingml/2011/main" val="0"/>
             </a:ext>
           </a:extLst>
         </p:spPr>
@@ -6138,6 +6019,36 @@
           </a:p>
         </p:txBody>
       </p:sp>
+      <p:pic>
+        <p:nvPicPr>
+          <p:cNvPr id="16" name="Grafik 15">
+            <a:extLst>
+              <a:ext uri="{FF2B5EF4-FFF2-40B4-BE49-F238E27FC236}">
+                <a16:creationId xmlns:a16="http://schemas.microsoft.com/office/drawing/2014/main" id="{91380333-5D34-79F1-94A4-4C7D12611105}"/>
+              </a:ext>
+            </a:extLst>
+          </p:cNvPr>
+          <p:cNvPicPr>
+            <a:picLocks noChangeAspect="1"/>
+          </p:cNvPicPr>
+          <p:nvPr/>
+        </p:nvPicPr>
+        <p:blipFill>
+          <a:blip r:embed="rId6"/>
+          <a:stretch>
+            <a:fillRect/>
+          </a:stretch>
+        </p:blipFill>
+        <p:spPr>
+          <a:xfrm>
+            <a:off x="244021" y="6051550"/>
+            <a:ext cx="4470400" cy="698500"/>
+          </a:xfrm>
+          <a:prstGeom prst="rect">
+            <a:avLst/>
+          </a:prstGeom>
+        </p:spPr>
+      </p:pic>
     </p:spTree>
   </p:cSld>
   <p:clrMapOvr>
@@ -6782,7 +6693,7 @@
                 <a:ea typeface="Calibri" pitchFamily="34" charset="-122"/>
                 <a:cs typeface="Calibri" pitchFamily="34" charset="-120"/>
               </a:rPr>
-              <a:t>Ziel: Daten automatisch in die Cloud – jederzeit, überall und als zweite Sicherung.</a:t>
+              <a:t>Ziel: Daten automatisch in die Cloud, jederzeit, überall und als zweite Sicherung.</a:t>
             </a:r>
             <a:endParaRPr lang="en-US" sz="2000" dirty="0"/>
           </a:p>
@@ -6808,7 +6719,7 @@
           </a:prstGeom>
           <a:extLst>
             <a:ext uri="{C572A759-6A51-4108-AA02-DFA0A04FC94B}">
-              <ma14:wrappingTextBoxFlag xmlns:ma14="http://schemas.microsoft.com/office/mac/drawingml/2011/main" xmlns="" val="0"/>
+              <ma14:wrappingTextBoxFlag xmlns="" xmlns:ma14="http://schemas.microsoft.com/office/mac/drawingml/2011/main" val="0"/>
             </a:ext>
           </a:extLst>
         </p:spPr>
@@ -6836,6 +6747,36 @@
           </a:p>
         </p:txBody>
       </p:sp>
+      <p:pic>
+        <p:nvPicPr>
+          <p:cNvPr id="21" name="Grafik 20">
+            <a:extLst>
+              <a:ext uri="{FF2B5EF4-FFF2-40B4-BE49-F238E27FC236}">
+                <a16:creationId xmlns:a16="http://schemas.microsoft.com/office/drawing/2014/main" id="{C1663880-C45C-08AE-F8C8-EB5D9DD6D0D9}"/>
+              </a:ext>
+            </a:extLst>
+          </p:cNvPr>
+          <p:cNvPicPr>
+            <a:picLocks noChangeAspect="1"/>
+          </p:cNvPicPr>
+          <p:nvPr/>
+        </p:nvPicPr>
+        <p:blipFill>
+          <a:blip r:embed="rId6"/>
+          <a:stretch>
+            <a:fillRect/>
+          </a:stretch>
+        </p:blipFill>
+        <p:spPr>
+          <a:xfrm>
+            <a:off x="480786" y="5989320"/>
+            <a:ext cx="4470400" cy="698500"/>
+          </a:xfrm>
+          <a:prstGeom prst="rect">
+            <a:avLst/>
+          </a:prstGeom>
+        </p:spPr>
+      </p:pic>
     </p:spTree>
   </p:cSld>
   <p:clrMapOvr>
@@ -8083,7 +8024,7 @@
           </a:prstGeom>
           <a:extLst>
             <a:ext uri="{C572A759-6A51-4108-AA02-DFA0A04FC94B}">
-              <ma14:wrappingTextBoxFlag xmlns:ma14="http://schemas.microsoft.com/office/mac/drawingml/2011/main" xmlns="" val="0"/>
+              <ma14:wrappingTextBoxFlag xmlns="" xmlns:ma14="http://schemas.microsoft.com/office/mac/drawingml/2011/main" val="0"/>
             </a:ext>
           </a:extLst>
         </p:spPr>
@@ -8111,6 +8052,36 @@
           </a:p>
         </p:txBody>
       </p:sp>
+      <p:pic>
+        <p:nvPicPr>
+          <p:cNvPr id="38" name="Grafik 37">
+            <a:extLst>
+              <a:ext uri="{FF2B5EF4-FFF2-40B4-BE49-F238E27FC236}">
+                <a16:creationId xmlns:a16="http://schemas.microsoft.com/office/drawing/2014/main" id="{8E151CF6-B5E2-7D2A-3871-2B2B7489909F}"/>
+              </a:ext>
+            </a:extLst>
+          </p:cNvPr>
+          <p:cNvPicPr>
+            <a:picLocks noChangeAspect="1"/>
+          </p:cNvPicPr>
+          <p:nvPr/>
+        </p:nvPicPr>
+        <p:blipFill>
+          <a:blip r:embed="rId8"/>
+          <a:stretch>
+            <a:fillRect/>
+          </a:stretch>
+        </p:blipFill>
+        <p:spPr>
+          <a:xfrm>
+            <a:off x="453136" y="5897880"/>
+            <a:ext cx="4470400" cy="698500"/>
+          </a:xfrm>
+          <a:prstGeom prst="rect">
+            <a:avLst/>
+          </a:prstGeom>
+        </p:spPr>
+      </p:pic>
     </p:spTree>
   </p:cSld>
   <p:clrMapOvr>
@@ -8212,7 +8183,7 @@
                 <a:ea typeface="Calibri" pitchFamily="34" charset="-122"/>
                 <a:cs typeface="Calibri" pitchFamily="34" charset="-120"/>
               </a:rPr>
-              <a:t>Wir folgen dem Bewertungsbogen</a:t>
+              <a:t>Agenda</a:t>
             </a:r>
             <a:endParaRPr lang="en-US" sz="3600" dirty="0"/>
           </a:p>
@@ -8227,14 +8198,14 @@
           <p:nvPr>
             <p:extLst>
               <p:ext uri="{D42A27DB-BD31-4B8C-83A1-F6EECF244321}">
-                <p14:modId xmlns:p14="http://schemas.microsoft.com/office/powerpoint/2010/main" val="1579011935"/>
+                <p14:modId xmlns:p14="http://schemas.microsoft.com/office/powerpoint/2010/main" val="3003269527"/>
               </p:ext>
             </p:extLst>
           </p:nvPr>
         </p:nvGraphicFramePr>
         <p:xfrm>
           <a:off x="640080" y="1783080"/>
-          <a:ext cx="10908792" cy="4114800"/>
+          <a:ext cx="7772400" cy="4114800"/>
         </p:xfrm>
         <a:graphic>
           <a:graphicData uri="http://schemas.openxmlformats.org/drawingml/2006/table">
@@ -8252,20 +8223,6 @@
                   <a:extLst>
                     <a:ext uri="{9D8B030D-6E8A-4147-A177-3AD203B41FA5}">
                       <a16:colId xmlns:a16="http://schemas.microsoft.com/office/drawing/2014/main" val="20001"/>
-                    </a:ext>
-                  </a:extLst>
-                </a:gridCol>
-                <a:gridCol w="1554480">
-                  <a:extLst>
-                    <a:ext uri="{9D8B030D-6E8A-4147-A177-3AD203B41FA5}">
-                      <a16:colId xmlns:a16="http://schemas.microsoft.com/office/drawing/2014/main" val="20002"/>
-                    </a:ext>
-                  </a:extLst>
-                </a:gridCol>
-                <a:gridCol w="1581912">
-                  <a:extLst>
-                    <a:ext uri="{9D8B030D-6E8A-4147-A177-3AD203B41FA5}">
-                      <a16:colId xmlns:a16="http://schemas.microsoft.com/office/drawing/2014/main" val="20003"/>
                     </a:ext>
                   </a:extLst>
                 </a:gridCol>
@@ -8357,142 +8314,6 @@
                           <a:cs typeface="Calibri" pitchFamily="34" charset="-120"/>
                         </a:rPr>
                         <a:t>Kriterium</a:t>
-                      </a:r>
-                      <a:endParaRPr lang="en-US" sz="1600" dirty="0">
-                        <a:latin typeface="Calibri" charset="0"/>
-                        <a:ea typeface="Calibri" charset="0"/>
-                        <a:cs typeface="Calibri" charset="0"/>
-                      </a:endParaRPr>
-                    </a:p>
-                  </a:txBody>
-                  <a:tcPr anchor="ctr">
-                    <a:lnL w="6350" cap="flat" cmpd="sng" algn="ctr">
-                      <a:solidFill>
-                        <a:srgbClr val="D3DEE6"/>
-                      </a:solidFill>
-                      <a:prstDash val="solid"/>
-                      <a:round/>
-                      <a:headEnd type="none" w="med" len="med"/>
-                      <a:tailEnd type="none" w="med" len="med"/>
-                    </a:lnL>
-                    <a:lnR w="6350" cap="flat" cmpd="sng" algn="ctr">
-                      <a:solidFill>
-                        <a:srgbClr val="D3DEE6"/>
-                      </a:solidFill>
-                      <a:prstDash val="solid"/>
-                      <a:round/>
-                      <a:headEnd type="none" w="med" len="med"/>
-                      <a:tailEnd type="none" w="med" len="med"/>
-                    </a:lnR>
-                    <a:lnT w="6350" cap="flat" cmpd="sng" algn="ctr">
-                      <a:solidFill>
-                        <a:srgbClr val="D3DEE6"/>
-                      </a:solidFill>
-                      <a:prstDash val="solid"/>
-                      <a:round/>
-                      <a:headEnd type="none" w="med" len="med"/>
-                      <a:tailEnd type="none" w="med" len="med"/>
-                    </a:lnT>
-                    <a:lnB w="6350" cap="flat" cmpd="sng" algn="ctr">
-                      <a:solidFill>
-                        <a:srgbClr val="D3DEE6"/>
-                      </a:solidFill>
-                      <a:prstDash val="solid"/>
-                      <a:round/>
-                      <a:headEnd type="none" w="med" len="med"/>
-                      <a:tailEnd type="none" w="med" len="med"/>
-                    </a:lnB>
-                    <a:solidFill>
-                      <a:srgbClr val="CBDAE4"/>
-                    </a:solidFill>
-                  </a:tcPr>
-                </a:tc>
-                <a:tc>
-                  <a:txBody>
-                    <a:bodyPr/>
-                    <a:lstStyle/>
-                    <a:p>
-                      <a:pPr marL="0" indent="0" algn="r">
-                        <a:buNone/>
-                      </a:pPr>
-                      <a:r>
-                        <a:rPr lang="en-US" sz="1600" b="1" dirty="0">
-                          <a:solidFill>
-                            <a:srgbClr val="0E1B2C"/>
-                          </a:solidFill>
-                          <a:latin typeface="Calibri" pitchFamily="34" charset="0"/>
-                          <a:ea typeface="Calibri" pitchFamily="34" charset="-122"/>
-                          <a:cs typeface="Calibri" pitchFamily="34" charset="-120"/>
-                        </a:rPr>
-                        <a:t>Punkte</a:t>
-                      </a:r>
-                      <a:endParaRPr lang="en-US" sz="1600" dirty="0">
-                        <a:latin typeface="Calibri" charset="0"/>
-                        <a:ea typeface="Calibri" charset="0"/>
-                        <a:cs typeface="Calibri" charset="0"/>
-                      </a:endParaRPr>
-                    </a:p>
-                  </a:txBody>
-                  <a:tcPr anchor="ctr">
-                    <a:lnL w="6350" cap="flat" cmpd="sng" algn="ctr">
-                      <a:solidFill>
-                        <a:srgbClr val="D3DEE6"/>
-                      </a:solidFill>
-                      <a:prstDash val="solid"/>
-                      <a:round/>
-                      <a:headEnd type="none" w="med" len="med"/>
-                      <a:tailEnd type="none" w="med" len="med"/>
-                    </a:lnL>
-                    <a:lnR w="6350" cap="flat" cmpd="sng" algn="ctr">
-                      <a:solidFill>
-                        <a:srgbClr val="D3DEE6"/>
-                      </a:solidFill>
-                      <a:prstDash val="solid"/>
-                      <a:round/>
-                      <a:headEnd type="none" w="med" len="med"/>
-                      <a:tailEnd type="none" w="med" len="med"/>
-                    </a:lnR>
-                    <a:lnT w="6350" cap="flat" cmpd="sng" algn="ctr">
-                      <a:solidFill>
-                        <a:srgbClr val="D3DEE6"/>
-                      </a:solidFill>
-                      <a:prstDash val="solid"/>
-                      <a:round/>
-                      <a:headEnd type="none" w="med" len="med"/>
-                      <a:tailEnd type="none" w="med" len="med"/>
-                    </a:lnT>
-                    <a:lnB w="6350" cap="flat" cmpd="sng" algn="ctr">
-                      <a:solidFill>
-                        <a:srgbClr val="D3DEE6"/>
-                      </a:solidFill>
-                      <a:prstDash val="solid"/>
-                      <a:round/>
-                      <a:headEnd type="none" w="med" len="med"/>
-                      <a:tailEnd type="none" w="med" len="med"/>
-                    </a:lnB>
-                    <a:solidFill>
-                      <a:srgbClr val="CBDAE4"/>
-                    </a:solidFill>
-                  </a:tcPr>
-                </a:tc>
-                <a:tc>
-                  <a:txBody>
-                    <a:bodyPr/>
-                    <a:lstStyle/>
-                    <a:p>
-                      <a:pPr marL="0" indent="0" algn="r">
-                        <a:buNone/>
-                      </a:pPr>
-                      <a:r>
-                        <a:rPr lang="en-US" sz="1600" b="1" dirty="0">
-                          <a:solidFill>
-                            <a:srgbClr val="0E1B2C"/>
-                          </a:solidFill>
-                          <a:latin typeface="Calibri" pitchFamily="34" charset="0"/>
-                          <a:ea typeface="Calibri" pitchFamily="34" charset="-122"/>
-                          <a:cs typeface="Calibri" pitchFamily="34" charset="-120"/>
-                        </a:rPr>
-                        <a:t>Folie</a:t>
                       </a:r>
                       <a:endParaRPr lang="en-US" sz="1600" dirty="0">
                         <a:latin typeface="Calibri" charset="0"/>
@@ -8686,142 +8507,6 @@
                     </a:solidFill>
                   </a:tcPr>
                 </a:tc>
-                <a:tc>
-                  <a:txBody>
-                    <a:bodyPr/>
-                    <a:lstStyle/>
-                    <a:p>
-                      <a:pPr marL="0" indent="0" algn="r">
-                        <a:buNone/>
-                      </a:pPr>
-                      <a:r>
-                        <a:rPr lang="en-US" sz="1600" dirty="0">
-                          <a:solidFill>
-                            <a:srgbClr val="3E4C5E"/>
-                          </a:solidFill>
-                          <a:latin typeface="Calibri" pitchFamily="34" charset="0"/>
-                          <a:ea typeface="Calibri" pitchFamily="34" charset="-122"/>
-                          <a:cs typeface="Calibri" pitchFamily="34" charset="-120"/>
-                        </a:rPr>
-                        <a:t>5</a:t>
-                      </a:r>
-                      <a:endParaRPr lang="en-US" sz="1600" dirty="0">
-                        <a:latin typeface="Calibri" charset="0"/>
-                        <a:ea typeface="Calibri" charset="0"/>
-                        <a:cs typeface="Calibri" charset="0"/>
-                      </a:endParaRPr>
-                    </a:p>
-                  </a:txBody>
-                  <a:tcPr anchor="ctr">
-                    <a:lnL w="6350" cap="flat" cmpd="sng" algn="ctr">
-                      <a:solidFill>
-                        <a:srgbClr val="D3DEE6"/>
-                      </a:solidFill>
-                      <a:prstDash val="solid"/>
-                      <a:round/>
-                      <a:headEnd type="none" w="med" len="med"/>
-                      <a:tailEnd type="none" w="med" len="med"/>
-                    </a:lnL>
-                    <a:lnR w="6350" cap="flat" cmpd="sng" algn="ctr">
-                      <a:solidFill>
-                        <a:srgbClr val="D3DEE6"/>
-                      </a:solidFill>
-                      <a:prstDash val="solid"/>
-                      <a:round/>
-                      <a:headEnd type="none" w="med" len="med"/>
-                      <a:tailEnd type="none" w="med" len="med"/>
-                    </a:lnR>
-                    <a:lnT w="6350" cap="flat" cmpd="sng" algn="ctr">
-                      <a:solidFill>
-                        <a:srgbClr val="D3DEE6"/>
-                      </a:solidFill>
-                      <a:prstDash val="solid"/>
-                      <a:round/>
-                      <a:headEnd type="none" w="med" len="med"/>
-                      <a:tailEnd type="none" w="med" len="med"/>
-                    </a:lnT>
-                    <a:lnB w="6350" cap="flat" cmpd="sng" algn="ctr">
-                      <a:solidFill>
-                        <a:srgbClr val="D3DEE6"/>
-                      </a:solidFill>
-                      <a:prstDash val="solid"/>
-                      <a:round/>
-                      <a:headEnd type="none" w="med" len="med"/>
-                      <a:tailEnd type="none" w="med" len="med"/>
-                    </a:lnB>
-                    <a:solidFill>
-                      <a:srgbClr val="FFFFFF"/>
-                    </a:solidFill>
-                  </a:tcPr>
-                </a:tc>
-                <a:tc>
-                  <a:txBody>
-                    <a:bodyPr/>
-                    <a:lstStyle/>
-                    <a:p>
-                      <a:pPr marL="0" indent="0" algn="r">
-                        <a:buNone/>
-                      </a:pPr>
-                      <a:r>
-                        <a:rPr lang="en-US" sz="1600" dirty="0">
-                          <a:solidFill>
-                            <a:srgbClr val="3E4C5E"/>
-                          </a:solidFill>
-                          <a:latin typeface="Calibri" pitchFamily="34" charset="0"/>
-                          <a:ea typeface="Calibri" pitchFamily="34" charset="-122"/>
-                          <a:cs typeface="Calibri" pitchFamily="34" charset="-120"/>
-                        </a:rPr>
-                        <a:t>5</a:t>
-                      </a:r>
-                      <a:endParaRPr lang="en-US" sz="1600" dirty="0">
-                        <a:latin typeface="Calibri" charset="0"/>
-                        <a:ea typeface="Calibri" charset="0"/>
-                        <a:cs typeface="Calibri" charset="0"/>
-                      </a:endParaRPr>
-                    </a:p>
-                  </a:txBody>
-                  <a:tcPr anchor="ctr">
-                    <a:lnL w="6350" cap="flat" cmpd="sng" algn="ctr">
-                      <a:solidFill>
-                        <a:srgbClr val="D3DEE6"/>
-                      </a:solidFill>
-                      <a:prstDash val="solid"/>
-                      <a:round/>
-                      <a:headEnd type="none" w="med" len="med"/>
-                      <a:tailEnd type="none" w="med" len="med"/>
-                    </a:lnL>
-                    <a:lnR w="6350" cap="flat" cmpd="sng" algn="ctr">
-                      <a:solidFill>
-                        <a:srgbClr val="D3DEE6"/>
-                      </a:solidFill>
-                      <a:prstDash val="solid"/>
-                      <a:round/>
-                      <a:headEnd type="none" w="med" len="med"/>
-                      <a:tailEnd type="none" w="med" len="med"/>
-                    </a:lnR>
-                    <a:lnT w="6350" cap="flat" cmpd="sng" algn="ctr">
-                      <a:solidFill>
-                        <a:srgbClr val="D3DEE6"/>
-                      </a:solidFill>
-                      <a:prstDash val="solid"/>
-                      <a:round/>
-                      <a:headEnd type="none" w="med" len="med"/>
-                      <a:tailEnd type="none" w="med" len="med"/>
-                    </a:lnT>
-                    <a:lnB w="6350" cap="flat" cmpd="sng" algn="ctr">
-                      <a:solidFill>
-                        <a:srgbClr val="D3DEE6"/>
-                      </a:solidFill>
-                      <a:prstDash val="solid"/>
-                      <a:round/>
-                      <a:headEnd type="none" w="med" len="med"/>
-                      <a:tailEnd type="none" w="med" len="med"/>
-                    </a:lnB>
-                    <a:solidFill>
-                      <a:srgbClr val="FFFFFF"/>
-                    </a:solidFill>
-                  </a:tcPr>
-                </a:tc>
                 <a:extLst>
                   <a:ext uri="{0D108BD9-81ED-4DB2-BD59-A6C34878D82A}">
                     <a16:rowId xmlns:a16="http://schemas.microsoft.com/office/drawing/2014/main" val="10001"/>
@@ -8915,142 +8600,6 @@
                           <a:cs typeface="Calibri" pitchFamily="34" charset="-120"/>
                         </a:rPr>
                         <a:t>Entscheidung technisch begründet</a:t>
-                      </a:r>
-                      <a:endParaRPr lang="en-US" sz="1600" dirty="0">
-                        <a:latin typeface="Calibri" charset="0"/>
-                        <a:ea typeface="Calibri" charset="0"/>
-                        <a:cs typeface="Calibri" charset="0"/>
-                      </a:endParaRPr>
-                    </a:p>
-                  </a:txBody>
-                  <a:tcPr anchor="ctr">
-                    <a:lnL w="6350" cap="flat" cmpd="sng" algn="ctr">
-                      <a:solidFill>
-                        <a:srgbClr val="D3DEE6"/>
-                      </a:solidFill>
-                      <a:prstDash val="solid"/>
-                      <a:round/>
-                      <a:headEnd type="none" w="med" len="med"/>
-                      <a:tailEnd type="none" w="med" len="med"/>
-                    </a:lnL>
-                    <a:lnR w="6350" cap="flat" cmpd="sng" algn="ctr">
-                      <a:solidFill>
-                        <a:srgbClr val="D3DEE6"/>
-                      </a:solidFill>
-                      <a:prstDash val="solid"/>
-                      <a:round/>
-                      <a:headEnd type="none" w="med" len="med"/>
-                      <a:tailEnd type="none" w="med" len="med"/>
-                    </a:lnR>
-                    <a:lnT w="6350" cap="flat" cmpd="sng" algn="ctr">
-                      <a:solidFill>
-                        <a:srgbClr val="D3DEE6"/>
-                      </a:solidFill>
-                      <a:prstDash val="solid"/>
-                      <a:round/>
-                      <a:headEnd type="none" w="med" len="med"/>
-                      <a:tailEnd type="none" w="med" len="med"/>
-                    </a:lnT>
-                    <a:lnB w="6350" cap="flat" cmpd="sng" algn="ctr">
-                      <a:solidFill>
-                        <a:srgbClr val="D3DEE6"/>
-                      </a:solidFill>
-                      <a:prstDash val="solid"/>
-                      <a:round/>
-                      <a:headEnd type="none" w="med" len="med"/>
-                      <a:tailEnd type="none" w="med" len="med"/>
-                    </a:lnB>
-                    <a:solidFill>
-                      <a:srgbClr val="F4F8FA"/>
-                    </a:solidFill>
-                  </a:tcPr>
-                </a:tc>
-                <a:tc>
-                  <a:txBody>
-                    <a:bodyPr/>
-                    <a:lstStyle/>
-                    <a:p>
-                      <a:pPr marL="0" indent="0" algn="r">
-                        <a:buNone/>
-                      </a:pPr>
-                      <a:r>
-                        <a:rPr lang="en-US" sz="1600" dirty="0">
-                          <a:solidFill>
-                            <a:srgbClr val="3E4C5E"/>
-                          </a:solidFill>
-                          <a:latin typeface="Calibri" pitchFamily="34" charset="0"/>
-                          <a:ea typeface="Calibri" pitchFamily="34" charset="-122"/>
-                          <a:cs typeface="Calibri" pitchFamily="34" charset="-120"/>
-                        </a:rPr>
-                        <a:t>5</a:t>
-                      </a:r>
-                      <a:endParaRPr lang="en-US" sz="1600" dirty="0">
-                        <a:latin typeface="Calibri" charset="0"/>
-                        <a:ea typeface="Calibri" charset="0"/>
-                        <a:cs typeface="Calibri" charset="0"/>
-                      </a:endParaRPr>
-                    </a:p>
-                  </a:txBody>
-                  <a:tcPr anchor="ctr">
-                    <a:lnL w="6350" cap="flat" cmpd="sng" algn="ctr">
-                      <a:solidFill>
-                        <a:srgbClr val="D3DEE6"/>
-                      </a:solidFill>
-                      <a:prstDash val="solid"/>
-                      <a:round/>
-                      <a:headEnd type="none" w="med" len="med"/>
-                      <a:tailEnd type="none" w="med" len="med"/>
-                    </a:lnL>
-                    <a:lnR w="6350" cap="flat" cmpd="sng" algn="ctr">
-                      <a:solidFill>
-                        <a:srgbClr val="D3DEE6"/>
-                      </a:solidFill>
-                      <a:prstDash val="solid"/>
-                      <a:round/>
-                      <a:headEnd type="none" w="med" len="med"/>
-                      <a:tailEnd type="none" w="med" len="med"/>
-                    </a:lnR>
-                    <a:lnT w="6350" cap="flat" cmpd="sng" algn="ctr">
-                      <a:solidFill>
-                        <a:srgbClr val="D3DEE6"/>
-                      </a:solidFill>
-                      <a:prstDash val="solid"/>
-                      <a:round/>
-                      <a:headEnd type="none" w="med" len="med"/>
-                      <a:tailEnd type="none" w="med" len="med"/>
-                    </a:lnT>
-                    <a:lnB w="6350" cap="flat" cmpd="sng" algn="ctr">
-                      <a:solidFill>
-                        <a:srgbClr val="D3DEE6"/>
-                      </a:solidFill>
-                      <a:prstDash val="solid"/>
-                      <a:round/>
-                      <a:headEnd type="none" w="med" len="med"/>
-                      <a:tailEnd type="none" w="med" len="med"/>
-                    </a:lnB>
-                    <a:solidFill>
-                      <a:srgbClr val="F4F8FA"/>
-                    </a:solidFill>
-                  </a:tcPr>
-                </a:tc>
-                <a:tc>
-                  <a:txBody>
-                    <a:bodyPr/>
-                    <a:lstStyle/>
-                    <a:p>
-                      <a:pPr marL="0" indent="0" algn="r">
-                        <a:buNone/>
-                      </a:pPr>
-                      <a:r>
-                        <a:rPr lang="en-US" sz="1600" dirty="0">
-                          <a:solidFill>
-                            <a:srgbClr val="3E4C5E"/>
-                          </a:solidFill>
-                          <a:latin typeface="Calibri" pitchFamily="34" charset="0"/>
-                          <a:ea typeface="Calibri" pitchFamily="34" charset="-122"/>
-                          <a:cs typeface="Calibri" pitchFamily="34" charset="-120"/>
-                        </a:rPr>
-                        <a:t>6</a:t>
                       </a:r>
                       <a:endParaRPr lang="en-US" sz="1600" dirty="0">
                         <a:latin typeface="Calibri" charset="0"/>
@@ -9244,142 +8793,6 @@
                     </a:solidFill>
                   </a:tcPr>
                 </a:tc>
-                <a:tc>
-                  <a:txBody>
-                    <a:bodyPr/>
-                    <a:lstStyle/>
-                    <a:p>
-                      <a:pPr marL="0" indent="0" algn="r">
-                        <a:buNone/>
-                      </a:pPr>
-                      <a:r>
-                        <a:rPr lang="en-US" sz="1600" dirty="0">
-                          <a:solidFill>
-                            <a:srgbClr val="3E4C5E"/>
-                          </a:solidFill>
-                          <a:latin typeface="Calibri" pitchFamily="34" charset="0"/>
-                          <a:ea typeface="Calibri" pitchFamily="34" charset="-122"/>
-                          <a:cs typeface="Calibri" pitchFamily="34" charset="-120"/>
-                        </a:rPr>
-                        <a:t>5</a:t>
-                      </a:r>
-                      <a:endParaRPr lang="en-US" sz="1600" dirty="0">
-                        <a:latin typeface="Calibri" charset="0"/>
-                        <a:ea typeface="Calibri" charset="0"/>
-                        <a:cs typeface="Calibri" charset="0"/>
-                      </a:endParaRPr>
-                    </a:p>
-                  </a:txBody>
-                  <a:tcPr anchor="ctr">
-                    <a:lnL w="6350" cap="flat" cmpd="sng" algn="ctr">
-                      <a:solidFill>
-                        <a:srgbClr val="D3DEE6"/>
-                      </a:solidFill>
-                      <a:prstDash val="solid"/>
-                      <a:round/>
-                      <a:headEnd type="none" w="med" len="med"/>
-                      <a:tailEnd type="none" w="med" len="med"/>
-                    </a:lnL>
-                    <a:lnR w="6350" cap="flat" cmpd="sng" algn="ctr">
-                      <a:solidFill>
-                        <a:srgbClr val="D3DEE6"/>
-                      </a:solidFill>
-                      <a:prstDash val="solid"/>
-                      <a:round/>
-                      <a:headEnd type="none" w="med" len="med"/>
-                      <a:tailEnd type="none" w="med" len="med"/>
-                    </a:lnR>
-                    <a:lnT w="6350" cap="flat" cmpd="sng" algn="ctr">
-                      <a:solidFill>
-                        <a:srgbClr val="D3DEE6"/>
-                      </a:solidFill>
-                      <a:prstDash val="solid"/>
-                      <a:round/>
-                      <a:headEnd type="none" w="med" len="med"/>
-                      <a:tailEnd type="none" w="med" len="med"/>
-                    </a:lnT>
-                    <a:lnB w="6350" cap="flat" cmpd="sng" algn="ctr">
-                      <a:solidFill>
-                        <a:srgbClr val="D3DEE6"/>
-                      </a:solidFill>
-                      <a:prstDash val="solid"/>
-                      <a:round/>
-                      <a:headEnd type="none" w="med" len="med"/>
-                      <a:tailEnd type="none" w="med" len="med"/>
-                    </a:lnB>
-                    <a:solidFill>
-                      <a:srgbClr val="FFFFFF"/>
-                    </a:solidFill>
-                  </a:tcPr>
-                </a:tc>
-                <a:tc>
-                  <a:txBody>
-                    <a:bodyPr/>
-                    <a:lstStyle/>
-                    <a:p>
-                      <a:pPr marL="0" indent="0" algn="r">
-                        <a:buNone/>
-                      </a:pPr>
-                      <a:r>
-                        <a:rPr lang="en-US" sz="1600" dirty="0">
-                          <a:solidFill>
-                            <a:srgbClr val="3E4C5E"/>
-                          </a:solidFill>
-                          <a:latin typeface="Calibri" pitchFamily="34" charset="0"/>
-                          <a:ea typeface="Calibri" pitchFamily="34" charset="-122"/>
-                          <a:cs typeface="Calibri" pitchFamily="34" charset="-120"/>
-                        </a:rPr>
-                        <a:t>7</a:t>
-                      </a:r>
-                      <a:endParaRPr lang="en-US" sz="1600" dirty="0">
-                        <a:latin typeface="Calibri" charset="0"/>
-                        <a:ea typeface="Calibri" charset="0"/>
-                        <a:cs typeface="Calibri" charset="0"/>
-                      </a:endParaRPr>
-                    </a:p>
-                  </a:txBody>
-                  <a:tcPr anchor="ctr">
-                    <a:lnL w="6350" cap="flat" cmpd="sng" algn="ctr">
-                      <a:solidFill>
-                        <a:srgbClr val="D3DEE6"/>
-                      </a:solidFill>
-                      <a:prstDash val="solid"/>
-                      <a:round/>
-                      <a:headEnd type="none" w="med" len="med"/>
-                      <a:tailEnd type="none" w="med" len="med"/>
-                    </a:lnL>
-                    <a:lnR w="6350" cap="flat" cmpd="sng" algn="ctr">
-                      <a:solidFill>
-                        <a:srgbClr val="D3DEE6"/>
-                      </a:solidFill>
-                      <a:prstDash val="solid"/>
-                      <a:round/>
-                      <a:headEnd type="none" w="med" len="med"/>
-                      <a:tailEnd type="none" w="med" len="med"/>
-                    </a:lnR>
-                    <a:lnT w="6350" cap="flat" cmpd="sng" algn="ctr">
-                      <a:solidFill>
-                        <a:srgbClr val="D3DEE6"/>
-                      </a:solidFill>
-                      <a:prstDash val="solid"/>
-                      <a:round/>
-                      <a:headEnd type="none" w="med" len="med"/>
-                      <a:tailEnd type="none" w="med" len="med"/>
-                    </a:lnT>
-                    <a:lnB w="6350" cap="flat" cmpd="sng" algn="ctr">
-                      <a:solidFill>
-                        <a:srgbClr val="D3DEE6"/>
-                      </a:solidFill>
-                      <a:prstDash val="solid"/>
-                      <a:round/>
-                      <a:headEnd type="none" w="med" len="med"/>
-                      <a:tailEnd type="none" w="med" len="med"/>
-                    </a:lnB>
-                    <a:solidFill>
-                      <a:srgbClr val="FFFFFF"/>
-                    </a:solidFill>
-                  </a:tcPr>
-                </a:tc>
                 <a:extLst>
                   <a:ext uri="{0D108BD9-81ED-4DB2-BD59-A6C34878D82A}">
                     <a16:rowId xmlns:a16="http://schemas.microsoft.com/office/drawing/2014/main" val="10003"/>
@@ -9473,142 +8886,6 @@
                           <a:cs typeface="Calibri" pitchFamily="34" charset="-120"/>
                         </a:rPr>
                         <a:t>Einordnung als IaaS, PaaS oder SaaS</a:t>
-                      </a:r>
-                      <a:endParaRPr lang="en-US" sz="1600" dirty="0">
-                        <a:latin typeface="Calibri" charset="0"/>
-                        <a:ea typeface="Calibri" charset="0"/>
-                        <a:cs typeface="Calibri" charset="0"/>
-                      </a:endParaRPr>
-                    </a:p>
-                  </a:txBody>
-                  <a:tcPr anchor="ctr">
-                    <a:lnL w="6350" cap="flat" cmpd="sng" algn="ctr">
-                      <a:solidFill>
-                        <a:srgbClr val="D3DEE6"/>
-                      </a:solidFill>
-                      <a:prstDash val="solid"/>
-                      <a:round/>
-                      <a:headEnd type="none" w="med" len="med"/>
-                      <a:tailEnd type="none" w="med" len="med"/>
-                    </a:lnL>
-                    <a:lnR w="6350" cap="flat" cmpd="sng" algn="ctr">
-                      <a:solidFill>
-                        <a:srgbClr val="D3DEE6"/>
-                      </a:solidFill>
-                      <a:prstDash val="solid"/>
-                      <a:round/>
-                      <a:headEnd type="none" w="med" len="med"/>
-                      <a:tailEnd type="none" w="med" len="med"/>
-                    </a:lnR>
-                    <a:lnT w="6350" cap="flat" cmpd="sng" algn="ctr">
-                      <a:solidFill>
-                        <a:srgbClr val="D3DEE6"/>
-                      </a:solidFill>
-                      <a:prstDash val="solid"/>
-                      <a:round/>
-                      <a:headEnd type="none" w="med" len="med"/>
-                      <a:tailEnd type="none" w="med" len="med"/>
-                    </a:lnT>
-                    <a:lnB w="6350" cap="flat" cmpd="sng" algn="ctr">
-                      <a:solidFill>
-                        <a:srgbClr val="D3DEE6"/>
-                      </a:solidFill>
-                      <a:prstDash val="solid"/>
-                      <a:round/>
-                      <a:headEnd type="none" w="med" len="med"/>
-                      <a:tailEnd type="none" w="med" len="med"/>
-                    </a:lnB>
-                    <a:solidFill>
-                      <a:srgbClr val="F4F8FA"/>
-                    </a:solidFill>
-                  </a:tcPr>
-                </a:tc>
-                <a:tc>
-                  <a:txBody>
-                    <a:bodyPr/>
-                    <a:lstStyle/>
-                    <a:p>
-                      <a:pPr marL="0" indent="0" algn="r">
-                        <a:buNone/>
-                      </a:pPr>
-                      <a:r>
-                        <a:rPr lang="en-US" sz="1600" dirty="0">
-                          <a:solidFill>
-                            <a:srgbClr val="3E4C5E"/>
-                          </a:solidFill>
-                          <a:latin typeface="Calibri" pitchFamily="34" charset="0"/>
-                          <a:ea typeface="Calibri" pitchFamily="34" charset="-122"/>
-                          <a:cs typeface="Calibri" pitchFamily="34" charset="-120"/>
-                        </a:rPr>
-                        <a:t>5</a:t>
-                      </a:r>
-                      <a:endParaRPr lang="en-US" sz="1600" dirty="0">
-                        <a:latin typeface="Calibri" charset="0"/>
-                        <a:ea typeface="Calibri" charset="0"/>
-                        <a:cs typeface="Calibri" charset="0"/>
-                      </a:endParaRPr>
-                    </a:p>
-                  </a:txBody>
-                  <a:tcPr anchor="ctr">
-                    <a:lnL w="6350" cap="flat" cmpd="sng" algn="ctr">
-                      <a:solidFill>
-                        <a:srgbClr val="D3DEE6"/>
-                      </a:solidFill>
-                      <a:prstDash val="solid"/>
-                      <a:round/>
-                      <a:headEnd type="none" w="med" len="med"/>
-                      <a:tailEnd type="none" w="med" len="med"/>
-                    </a:lnL>
-                    <a:lnR w="6350" cap="flat" cmpd="sng" algn="ctr">
-                      <a:solidFill>
-                        <a:srgbClr val="D3DEE6"/>
-                      </a:solidFill>
-                      <a:prstDash val="solid"/>
-                      <a:round/>
-                      <a:headEnd type="none" w="med" len="med"/>
-                      <a:tailEnd type="none" w="med" len="med"/>
-                    </a:lnR>
-                    <a:lnT w="6350" cap="flat" cmpd="sng" algn="ctr">
-                      <a:solidFill>
-                        <a:srgbClr val="D3DEE6"/>
-                      </a:solidFill>
-                      <a:prstDash val="solid"/>
-                      <a:round/>
-                      <a:headEnd type="none" w="med" len="med"/>
-                      <a:tailEnd type="none" w="med" len="med"/>
-                    </a:lnT>
-                    <a:lnB w="6350" cap="flat" cmpd="sng" algn="ctr">
-                      <a:solidFill>
-                        <a:srgbClr val="D3DEE6"/>
-                      </a:solidFill>
-                      <a:prstDash val="solid"/>
-                      <a:round/>
-                      <a:headEnd type="none" w="med" len="med"/>
-                      <a:tailEnd type="none" w="med" len="med"/>
-                    </a:lnB>
-                    <a:solidFill>
-                      <a:srgbClr val="F4F8FA"/>
-                    </a:solidFill>
-                  </a:tcPr>
-                </a:tc>
-                <a:tc>
-                  <a:txBody>
-                    <a:bodyPr/>
-                    <a:lstStyle/>
-                    <a:p>
-                      <a:pPr marL="0" indent="0" algn="r">
-                        <a:buNone/>
-                      </a:pPr>
-                      <a:r>
-                        <a:rPr lang="en-US" sz="1600" dirty="0">
-                          <a:solidFill>
-                            <a:srgbClr val="3E4C5E"/>
-                          </a:solidFill>
-                          <a:latin typeface="Calibri" pitchFamily="34" charset="0"/>
-                          <a:ea typeface="Calibri" pitchFamily="34" charset="-122"/>
-                          <a:cs typeface="Calibri" pitchFamily="34" charset="-120"/>
-                        </a:rPr>
-                        <a:t>8</a:t>
                       </a:r>
                       <a:endParaRPr lang="en-US" sz="1600" dirty="0">
                         <a:latin typeface="Calibri" charset="0"/>
@@ -9802,142 +9079,6 @@
                     </a:solidFill>
                   </a:tcPr>
                 </a:tc>
-                <a:tc>
-                  <a:txBody>
-                    <a:bodyPr/>
-                    <a:lstStyle/>
-                    <a:p>
-                      <a:pPr marL="0" indent="0" algn="r">
-                        <a:buNone/>
-                      </a:pPr>
-                      <a:r>
-                        <a:rPr lang="en-US" sz="1600" dirty="0">
-                          <a:solidFill>
-                            <a:srgbClr val="3E4C5E"/>
-                          </a:solidFill>
-                          <a:latin typeface="Calibri" pitchFamily="34" charset="0"/>
-                          <a:ea typeface="Calibri" pitchFamily="34" charset="-122"/>
-                          <a:cs typeface="Calibri" pitchFamily="34" charset="-120"/>
-                        </a:rPr>
-                        <a:t>5</a:t>
-                      </a:r>
-                      <a:endParaRPr lang="en-US" sz="1600" dirty="0">
-                        <a:latin typeface="Calibri" charset="0"/>
-                        <a:ea typeface="Calibri" charset="0"/>
-                        <a:cs typeface="Calibri" charset="0"/>
-                      </a:endParaRPr>
-                    </a:p>
-                  </a:txBody>
-                  <a:tcPr anchor="ctr">
-                    <a:lnL w="6350" cap="flat" cmpd="sng" algn="ctr">
-                      <a:solidFill>
-                        <a:srgbClr val="D3DEE6"/>
-                      </a:solidFill>
-                      <a:prstDash val="solid"/>
-                      <a:round/>
-                      <a:headEnd type="none" w="med" len="med"/>
-                      <a:tailEnd type="none" w="med" len="med"/>
-                    </a:lnL>
-                    <a:lnR w="6350" cap="flat" cmpd="sng" algn="ctr">
-                      <a:solidFill>
-                        <a:srgbClr val="D3DEE6"/>
-                      </a:solidFill>
-                      <a:prstDash val="solid"/>
-                      <a:round/>
-                      <a:headEnd type="none" w="med" len="med"/>
-                      <a:tailEnd type="none" w="med" len="med"/>
-                    </a:lnR>
-                    <a:lnT w="6350" cap="flat" cmpd="sng" algn="ctr">
-                      <a:solidFill>
-                        <a:srgbClr val="D3DEE6"/>
-                      </a:solidFill>
-                      <a:prstDash val="solid"/>
-                      <a:round/>
-                      <a:headEnd type="none" w="med" len="med"/>
-                      <a:tailEnd type="none" w="med" len="med"/>
-                    </a:lnT>
-                    <a:lnB w="6350" cap="flat" cmpd="sng" algn="ctr">
-                      <a:solidFill>
-                        <a:srgbClr val="D3DEE6"/>
-                      </a:solidFill>
-                      <a:prstDash val="solid"/>
-                      <a:round/>
-                      <a:headEnd type="none" w="med" len="med"/>
-                      <a:tailEnd type="none" w="med" len="med"/>
-                    </a:lnB>
-                    <a:solidFill>
-                      <a:srgbClr val="FFFFFF"/>
-                    </a:solidFill>
-                  </a:tcPr>
-                </a:tc>
-                <a:tc>
-                  <a:txBody>
-                    <a:bodyPr/>
-                    <a:lstStyle/>
-                    <a:p>
-                      <a:pPr marL="0" indent="0" algn="r">
-                        <a:buNone/>
-                      </a:pPr>
-                      <a:r>
-                        <a:rPr lang="en-US" sz="1600" dirty="0">
-                          <a:solidFill>
-                            <a:srgbClr val="3E4C5E"/>
-                          </a:solidFill>
-                          <a:latin typeface="Calibri" pitchFamily="34" charset="0"/>
-                          <a:ea typeface="Calibri" pitchFamily="34" charset="-122"/>
-                          <a:cs typeface="Calibri" pitchFamily="34" charset="-120"/>
-                        </a:rPr>
-                        <a:t>9</a:t>
-                      </a:r>
-                      <a:endParaRPr lang="en-US" sz="1600" dirty="0">
-                        <a:latin typeface="Calibri" charset="0"/>
-                        <a:ea typeface="Calibri" charset="0"/>
-                        <a:cs typeface="Calibri" charset="0"/>
-                      </a:endParaRPr>
-                    </a:p>
-                  </a:txBody>
-                  <a:tcPr anchor="ctr">
-                    <a:lnL w="6350" cap="flat" cmpd="sng" algn="ctr">
-                      <a:solidFill>
-                        <a:srgbClr val="D3DEE6"/>
-                      </a:solidFill>
-                      <a:prstDash val="solid"/>
-                      <a:round/>
-                      <a:headEnd type="none" w="med" len="med"/>
-                      <a:tailEnd type="none" w="med" len="med"/>
-                    </a:lnL>
-                    <a:lnR w="6350" cap="flat" cmpd="sng" algn="ctr">
-                      <a:solidFill>
-                        <a:srgbClr val="D3DEE6"/>
-                      </a:solidFill>
-                      <a:prstDash val="solid"/>
-                      <a:round/>
-                      <a:headEnd type="none" w="med" len="med"/>
-                      <a:tailEnd type="none" w="med" len="med"/>
-                    </a:lnR>
-                    <a:lnT w="6350" cap="flat" cmpd="sng" algn="ctr">
-                      <a:solidFill>
-                        <a:srgbClr val="D3DEE6"/>
-                      </a:solidFill>
-                      <a:prstDash val="solid"/>
-                      <a:round/>
-                      <a:headEnd type="none" w="med" len="med"/>
-                      <a:tailEnd type="none" w="med" len="med"/>
-                    </a:lnT>
-                    <a:lnB w="6350" cap="flat" cmpd="sng" algn="ctr">
-                      <a:solidFill>
-                        <a:srgbClr val="D3DEE6"/>
-                      </a:solidFill>
-                      <a:prstDash val="solid"/>
-                      <a:round/>
-                      <a:headEnd type="none" w="med" len="med"/>
-                      <a:tailEnd type="none" w="med" len="med"/>
-                    </a:lnB>
-                    <a:solidFill>
-                      <a:srgbClr val="FFFFFF"/>
-                    </a:solidFill>
-                  </a:tcPr>
-                </a:tc>
                 <a:extLst>
                   <a:ext uri="{0D108BD9-81ED-4DB2-BD59-A6C34878D82A}">
                     <a16:rowId xmlns:a16="http://schemas.microsoft.com/office/drawing/2014/main" val="10005"/>
@@ -10031,142 +9172,6 @@
                           <a:cs typeface="Calibri" pitchFamily="34" charset="-120"/>
                         </a:rPr>
                         <a:t>Konzept zur sicheren Datenübertragung</a:t>
-                      </a:r>
-                      <a:endParaRPr lang="en-US" sz="1600" dirty="0">
-                        <a:latin typeface="Calibri" charset="0"/>
-                        <a:ea typeface="Calibri" charset="0"/>
-                        <a:cs typeface="Calibri" charset="0"/>
-                      </a:endParaRPr>
-                    </a:p>
-                  </a:txBody>
-                  <a:tcPr anchor="ctr">
-                    <a:lnL w="6350" cap="flat" cmpd="sng" algn="ctr">
-                      <a:solidFill>
-                        <a:srgbClr val="D3DEE6"/>
-                      </a:solidFill>
-                      <a:prstDash val="solid"/>
-                      <a:round/>
-                      <a:headEnd type="none" w="med" len="med"/>
-                      <a:tailEnd type="none" w="med" len="med"/>
-                    </a:lnL>
-                    <a:lnR w="6350" cap="flat" cmpd="sng" algn="ctr">
-                      <a:solidFill>
-                        <a:srgbClr val="D3DEE6"/>
-                      </a:solidFill>
-                      <a:prstDash val="solid"/>
-                      <a:round/>
-                      <a:headEnd type="none" w="med" len="med"/>
-                      <a:tailEnd type="none" w="med" len="med"/>
-                    </a:lnR>
-                    <a:lnT w="6350" cap="flat" cmpd="sng" algn="ctr">
-                      <a:solidFill>
-                        <a:srgbClr val="D3DEE6"/>
-                      </a:solidFill>
-                      <a:prstDash val="solid"/>
-                      <a:round/>
-                      <a:headEnd type="none" w="med" len="med"/>
-                      <a:tailEnd type="none" w="med" len="med"/>
-                    </a:lnT>
-                    <a:lnB w="6350" cap="flat" cmpd="sng" algn="ctr">
-                      <a:solidFill>
-                        <a:srgbClr val="D3DEE6"/>
-                      </a:solidFill>
-                      <a:prstDash val="solid"/>
-                      <a:round/>
-                      <a:headEnd type="none" w="med" len="med"/>
-                      <a:tailEnd type="none" w="med" len="med"/>
-                    </a:lnB>
-                    <a:solidFill>
-                      <a:srgbClr val="F4F8FA"/>
-                    </a:solidFill>
-                  </a:tcPr>
-                </a:tc>
-                <a:tc>
-                  <a:txBody>
-                    <a:bodyPr/>
-                    <a:lstStyle/>
-                    <a:p>
-                      <a:pPr marL="0" indent="0" algn="r">
-                        <a:buNone/>
-                      </a:pPr>
-                      <a:r>
-                        <a:rPr lang="en-US" sz="1600" dirty="0">
-                          <a:solidFill>
-                            <a:srgbClr val="3E4C5E"/>
-                          </a:solidFill>
-                          <a:latin typeface="Calibri" pitchFamily="34" charset="0"/>
-                          <a:ea typeface="Calibri" pitchFamily="34" charset="-122"/>
-                          <a:cs typeface="Calibri" pitchFamily="34" charset="-120"/>
-                        </a:rPr>
-                        <a:t>10</a:t>
-                      </a:r>
-                      <a:endParaRPr lang="en-US" sz="1600" dirty="0">
-                        <a:latin typeface="Calibri" charset="0"/>
-                        <a:ea typeface="Calibri" charset="0"/>
-                        <a:cs typeface="Calibri" charset="0"/>
-                      </a:endParaRPr>
-                    </a:p>
-                  </a:txBody>
-                  <a:tcPr anchor="ctr">
-                    <a:lnL w="6350" cap="flat" cmpd="sng" algn="ctr">
-                      <a:solidFill>
-                        <a:srgbClr val="D3DEE6"/>
-                      </a:solidFill>
-                      <a:prstDash val="solid"/>
-                      <a:round/>
-                      <a:headEnd type="none" w="med" len="med"/>
-                      <a:tailEnd type="none" w="med" len="med"/>
-                    </a:lnL>
-                    <a:lnR w="6350" cap="flat" cmpd="sng" algn="ctr">
-                      <a:solidFill>
-                        <a:srgbClr val="D3DEE6"/>
-                      </a:solidFill>
-                      <a:prstDash val="solid"/>
-                      <a:round/>
-                      <a:headEnd type="none" w="med" len="med"/>
-                      <a:tailEnd type="none" w="med" len="med"/>
-                    </a:lnR>
-                    <a:lnT w="6350" cap="flat" cmpd="sng" algn="ctr">
-                      <a:solidFill>
-                        <a:srgbClr val="D3DEE6"/>
-                      </a:solidFill>
-                      <a:prstDash val="solid"/>
-                      <a:round/>
-                      <a:headEnd type="none" w="med" len="med"/>
-                      <a:tailEnd type="none" w="med" len="med"/>
-                    </a:lnT>
-                    <a:lnB w="6350" cap="flat" cmpd="sng" algn="ctr">
-                      <a:solidFill>
-                        <a:srgbClr val="D3DEE6"/>
-                      </a:solidFill>
-                      <a:prstDash val="solid"/>
-                      <a:round/>
-                      <a:headEnd type="none" w="med" len="med"/>
-                      <a:tailEnd type="none" w="med" len="med"/>
-                    </a:lnB>
-                    <a:solidFill>
-                      <a:srgbClr val="F4F8FA"/>
-                    </a:solidFill>
-                  </a:tcPr>
-                </a:tc>
-                <a:tc>
-                  <a:txBody>
-                    <a:bodyPr/>
-                    <a:lstStyle/>
-                    <a:p>
-                      <a:pPr marL="0" indent="0" algn="r">
-                        <a:buNone/>
-                      </a:pPr>
-                      <a:r>
-                        <a:rPr lang="en-US" sz="1600" dirty="0">
-                          <a:solidFill>
-                            <a:srgbClr val="3E4C5E"/>
-                          </a:solidFill>
-                          <a:latin typeface="Calibri" pitchFamily="34" charset="0"/>
-                          <a:ea typeface="Calibri" pitchFamily="34" charset="-122"/>
-                          <a:cs typeface="Calibri" pitchFamily="34" charset="-120"/>
-                        </a:rPr>
-                        <a:t>10</a:t>
                       </a:r>
                       <a:endParaRPr lang="en-US" sz="1600" dirty="0">
                         <a:latin typeface="Calibri" charset="0"/>
@@ -10360,142 +9365,6 @@
                     </a:solidFill>
                   </a:tcPr>
                 </a:tc>
-                <a:tc>
-                  <a:txBody>
-                    <a:bodyPr/>
-                    <a:lstStyle/>
-                    <a:p>
-                      <a:pPr marL="0" indent="0" algn="r">
-                        <a:buNone/>
-                      </a:pPr>
-                      <a:r>
-                        <a:rPr lang="en-US" sz="1600" dirty="0">
-                          <a:solidFill>
-                            <a:srgbClr val="3E4C5E"/>
-                          </a:solidFill>
-                          <a:latin typeface="Calibri" pitchFamily="34" charset="0"/>
-                          <a:ea typeface="Calibri" pitchFamily="34" charset="-122"/>
-                          <a:cs typeface="Calibri" pitchFamily="34" charset="-120"/>
-                        </a:rPr>
-                        <a:t>10</a:t>
-                      </a:r>
-                      <a:endParaRPr lang="en-US" sz="1600" dirty="0">
-                        <a:latin typeface="Calibri" charset="0"/>
-                        <a:ea typeface="Calibri" charset="0"/>
-                        <a:cs typeface="Calibri" charset="0"/>
-                      </a:endParaRPr>
-                    </a:p>
-                  </a:txBody>
-                  <a:tcPr anchor="ctr">
-                    <a:lnL w="6350" cap="flat" cmpd="sng" algn="ctr">
-                      <a:solidFill>
-                        <a:srgbClr val="D3DEE6"/>
-                      </a:solidFill>
-                      <a:prstDash val="solid"/>
-                      <a:round/>
-                      <a:headEnd type="none" w="med" len="med"/>
-                      <a:tailEnd type="none" w="med" len="med"/>
-                    </a:lnL>
-                    <a:lnR w="6350" cap="flat" cmpd="sng" algn="ctr">
-                      <a:solidFill>
-                        <a:srgbClr val="D3DEE6"/>
-                      </a:solidFill>
-                      <a:prstDash val="solid"/>
-                      <a:round/>
-                      <a:headEnd type="none" w="med" len="med"/>
-                      <a:tailEnd type="none" w="med" len="med"/>
-                    </a:lnR>
-                    <a:lnT w="6350" cap="flat" cmpd="sng" algn="ctr">
-                      <a:solidFill>
-                        <a:srgbClr val="D3DEE6"/>
-                      </a:solidFill>
-                      <a:prstDash val="solid"/>
-                      <a:round/>
-                      <a:headEnd type="none" w="med" len="med"/>
-                      <a:tailEnd type="none" w="med" len="med"/>
-                    </a:lnT>
-                    <a:lnB w="6350" cap="flat" cmpd="sng" algn="ctr">
-                      <a:solidFill>
-                        <a:srgbClr val="D3DEE6"/>
-                      </a:solidFill>
-                      <a:prstDash val="solid"/>
-                      <a:round/>
-                      <a:headEnd type="none" w="med" len="med"/>
-                      <a:tailEnd type="none" w="med" len="med"/>
-                    </a:lnB>
-                    <a:solidFill>
-                      <a:srgbClr val="FFFFFF"/>
-                    </a:solidFill>
-                  </a:tcPr>
-                </a:tc>
-                <a:tc>
-                  <a:txBody>
-                    <a:bodyPr/>
-                    <a:lstStyle/>
-                    <a:p>
-                      <a:pPr marL="0" indent="0" algn="r">
-                        <a:buNone/>
-                      </a:pPr>
-                      <a:r>
-                        <a:rPr lang="en-US" sz="1600" dirty="0">
-                          <a:solidFill>
-                            <a:srgbClr val="3E4C5E"/>
-                          </a:solidFill>
-                          <a:latin typeface="Calibri" pitchFamily="34" charset="0"/>
-                          <a:ea typeface="Calibri" pitchFamily="34" charset="-122"/>
-                          <a:cs typeface="Calibri" pitchFamily="34" charset="-120"/>
-                        </a:rPr>
-                        <a:t>11</a:t>
-                      </a:r>
-                      <a:endParaRPr lang="en-US" sz="1600" dirty="0">
-                        <a:latin typeface="Calibri" charset="0"/>
-                        <a:ea typeface="Calibri" charset="0"/>
-                        <a:cs typeface="Calibri" charset="0"/>
-                      </a:endParaRPr>
-                    </a:p>
-                  </a:txBody>
-                  <a:tcPr anchor="ctr">
-                    <a:lnL w="6350" cap="flat" cmpd="sng" algn="ctr">
-                      <a:solidFill>
-                        <a:srgbClr val="D3DEE6"/>
-                      </a:solidFill>
-                      <a:prstDash val="solid"/>
-                      <a:round/>
-                      <a:headEnd type="none" w="med" len="med"/>
-                      <a:tailEnd type="none" w="med" len="med"/>
-                    </a:lnL>
-                    <a:lnR w="6350" cap="flat" cmpd="sng" algn="ctr">
-                      <a:solidFill>
-                        <a:srgbClr val="D3DEE6"/>
-                      </a:solidFill>
-                      <a:prstDash val="solid"/>
-                      <a:round/>
-                      <a:headEnd type="none" w="med" len="med"/>
-                      <a:tailEnd type="none" w="med" len="med"/>
-                    </a:lnR>
-                    <a:lnT w="6350" cap="flat" cmpd="sng" algn="ctr">
-                      <a:solidFill>
-                        <a:srgbClr val="D3DEE6"/>
-                      </a:solidFill>
-                      <a:prstDash val="solid"/>
-                      <a:round/>
-                      <a:headEnd type="none" w="med" len="med"/>
-                      <a:tailEnd type="none" w="med" len="med"/>
-                    </a:lnT>
-                    <a:lnB w="6350" cap="flat" cmpd="sng" algn="ctr">
-                      <a:solidFill>
-                        <a:srgbClr val="D3DEE6"/>
-                      </a:solidFill>
-                      <a:prstDash val="solid"/>
-                      <a:round/>
-                      <a:headEnd type="none" w="med" len="med"/>
-                      <a:tailEnd type="none" w="med" len="med"/>
-                    </a:lnB>
-                    <a:solidFill>
-                      <a:srgbClr val="FFFFFF"/>
-                    </a:solidFill>
-                  </a:tcPr>
-                </a:tc>
                 <a:extLst>
                   <a:ext uri="{0D108BD9-81ED-4DB2-BD59-A6C34878D82A}">
                     <a16:rowId xmlns:a16="http://schemas.microsoft.com/office/drawing/2014/main" val="10007"/>
@@ -10639,142 +9508,6 @@
                     </a:solidFill>
                   </a:tcPr>
                 </a:tc>
-                <a:tc>
-                  <a:txBody>
-                    <a:bodyPr/>
-                    <a:lstStyle/>
-                    <a:p>
-                      <a:pPr marL="0" indent="0" algn="r">
-                        <a:buNone/>
-                      </a:pPr>
-                      <a:r>
-                        <a:rPr lang="en-US" sz="1600" dirty="0">
-                          <a:solidFill>
-                            <a:srgbClr val="3E4C5E"/>
-                          </a:solidFill>
-                          <a:latin typeface="Calibri" pitchFamily="34" charset="0"/>
-                          <a:ea typeface="Calibri" pitchFamily="34" charset="-122"/>
-                          <a:cs typeface="Calibri" pitchFamily="34" charset="-120"/>
-                        </a:rPr>
-                        <a:t>5</a:t>
-                      </a:r>
-                      <a:endParaRPr lang="en-US" sz="1600" dirty="0">
-                        <a:latin typeface="Calibri" charset="0"/>
-                        <a:ea typeface="Calibri" charset="0"/>
-                        <a:cs typeface="Calibri" charset="0"/>
-                      </a:endParaRPr>
-                    </a:p>
-                  </a:txBody>
-                  <a:tcPr anchor="ctr">
-                    <a:lnL w="6350" cap="flat" cmpd="sng" algn="ctr">
-                      <a:solidFill>
-                        <a:srgbClr val="D3DEE6"/>
-                      </a:solidFill>
-                      <a:prstDash val="solid"/>
-                      <a:round/>
-                      <a:headEnd type="none" w="med" len="med"/>
-                      <a:tailEnd type="none" w="med" len="med"/>
-                    </a:lnL>
-                    <a:lnR w="6350" cap="flat" cmpd="sng" algn="ctr">
-                      <a:solidFill>
-                        <a:srgbClr val="D3DEE6"/>
-                      </a:solidFill>
-                      <a:prstDash val="solid"/>
-                      <a:round/>
-                      <a:headEnd type="none" w="med" len="med"/>
-                      <a:tailEnd type="none" w="med" len="med"/>
-                    </a:lnR>
-                    <a:lnT w="6350" cap="flat" cmpd="sng" algn="ctr">
-                      <a:solidFill>
-                        <a:srgbClr val="D3DEE6"/>
-                      </a:solidFill>
-                      <a:prstDash val="solid"/>
-                      <a:round/>
-                      <a:headEnd type="none" w="med" len="med"/>
-                      <a:tailEnd type="none" w="med" len="med"/>
-                    </a:lnT>
-                    <a:lnB w="6350" cap="flat" cmpd="sng" algn="ctr">
-                      <a:solidFill>
-                        <a:srgbClr val="D3DEE6"/>
-                      </a:solidFill>
-                      <a:prstDash val="solid"/>
-                      <a:round/>
-                      <a:headEnd type="none" w="med" len="med"/>
-                      <a:tailEnd type="none" w="med" len="med"/>
-                    </a:lnB>
-                    <a:solidFill>
-                      <a:srgbClr val="F4F8FA"/>
-                    </a:solidFill>
-                  </a:tcPr>
-                </a:tc>
-                <a:tc>
-                  <a:txBody>
-                    <a:bodyPr/>
-                    <a:lstStyle/>
-                    <a:p>
-                      <a:pPr marL="0" indent="0" algn="r">
-                        <a:buNone/>
-                      </a:pPr>
-                      <a:r>
-                        <a:rPr lang="en-US" sz="1600" dirty="0">
-                          <a:solidFill>
-                            <a:srgbClr val="3E4C5E"/>
-                          </a:solidFill>
-                          <a:latin typeface="Calibri" pitchFamily="34" charset="0"/>
-                          <a:ea typeface="Calibri" pitchFamily="34" charset="-122"/>
-                          <a:cs typeface="Calibri" pitchFamily="34" charset="-120"/>
-                        </a:rPr>
-                        <a:t>12</a:t>
-                      </a:r>
-                      <a:endParaRPr lang="en-US" sz="1600" dirty="0">
-                        <a:latin typeface="Calibri" charset="0"/>
-                        <a:ea typeface="Calibri" charset="0"/>
-                        <a:cs typeface="Calibri" charset="0"/>
-                      </a:endParaRPr>
-                    </a:p>
-                  </a:txBody>
-                  <a:tcPr anchor="ctr">
-                    <a:lnL w="6350" cap="flat" cmpd="sng" algn="ctr">
-                      <a:solidFill>
-                        <a:srgbClr val="D3DEE6"/>
-                      </a:solidFill>
-                      <a:prstDash val="solid"/>
-                      <a:round/>
-                      <a:headEnd type="none" w="med" len="med"/>
-                      <a:tailEnd type="none" w="med" len="med"/>
-                    </a:lnL>
-                    <a:lnR w="6350" cap="flat" cmpd="sng" algn="ctr">
-                      <a:solidFill>
-                        <a:srgbClr val="D3DEE6"/>
-                      </a:solidFill>
-                      <a:prstDash val="solid"/>
-                      <a:round/>
-                      <a:headEnd type="none" w="med" len="med"/>
-                      <a:tailEnd type="none" w="med" len="med"/>
-                    </a:lnR>
-                    <a:lnT w="6350" cap="flat" cmpd="sng" algn="ctr">
-                      <a:solidFill>
-                        <a:srgbClr val="D3DEE6"/>
-                      </a:solidFill>
-                      <a:prstDash val="solid"/>
-                      <a:round/>
-                      <a:headEnd type="none" w="med" len="med"/>
-                      <a:tailEnd type="none" w="med" len="med"/>
-                    </a:lnT>
-                    <a:lnB w="6350" cap="flat" cmpd="sng" algn="ctr">
-                      <a:solidFill>
-                        <a:srgbClr val="D3DEE6"/>
-                      </a:solidFill>
-                      <a:prstDash val="solid"/>
-                      <a:round/>
-                      <a:headEnd type="none" w="med" len="med"/>
-                      <a:tailEnd type="none" w="med" len="med"/>
-                    </a:lnB>
-                    <a:solidFill>
-                      <a:srgbClr val="F4F8FA"/>
-                    </a:solidFill>
-                  </a:tcPr>
-                </a:tc>
                 <a:extLst>
                   <a:ext uri="{0D108BD9-81ED-4DB2-BD59-A6C34878D82A}">
                     <a16:rowId xmlns:a16="http://schemas.microsoft.com/office/drawing/2014/main" val="10008"/>
@@ -10805,7 +9538,7 @@
           </a:prstGeom>
           <a:extLst>
             <a:ext uri="{C572A759-6A51-4108-AA02-DFA0A04FC94B}">
-              <ma14:wrappingTextBoxFlag xmlns:ma14="http://schemas.microsoft.com/office/mac/drawingml/2011/main" xmlns="" val="0"/>
+              <ma14:wrappingTextBoxFlag xmlns="" xmlns:ma14="http://schemas.microsoft.com/office/mac/drawingml/2011/main" val="0"/>
             </a:ext>
           </a:extLst>
         </p:spPr>
@@ -10833,6 +9566,36 @@
           </a:p>
         </p:txBody>
       </p:sp>
+      <p:pic>
+        <p:nvPicPr>
+          <p:cNvPr id="4" name="Grafik 3">
+            <a:extLst>
+              <a:ext uri="{FF2B5EF4-FFF2-40B4-BE49-F238E27FC236}">
+                <a16:creationId xmlns:a16="http://schemas.microsoft.com/office/drawing/2014/main" id="{88E89417-271D-3DB2-4977-E036CA03C7AB}"/>
+              </a:ext>
+            </a:extLst>
+          </p:cNvPr>
+          <p:cNvPicPr>
+            <a:picLocks noChangeAspect="1"/>
+          </p:cNvPicPr>
+          <p:nvPr/>
+        </p:nvPicPr>
+        <p:blipFill>
+          <a:blip r:embed="rId3"/>
+          <a:stretch>
+            <a:fillRect/>
+          </a:stretch>
+        </p:blipFill>
+        <p:spPr>
+          <a:xfrm>
+            <a:off x="444972" y="6051550"/>
+            <a:ext cx="4470400" cy="698500"/>
+          </a:xfrm>
+          <a:prstGeom prst="rect">
+            <a:avLst/>
+          </a:prstGeom>
+        </p:spPr>
+      </p:pic>
     </p:spTree>
   </p:cSld>
   <p:clrMapOvr>
@@ -10894,49 +9657,6 @@
               <a:t>KRITERIUM 1 · MINDESTENS ZWEI CLOUDDIENSTE</a:t>
             </a:r>
             <a:endParaRPr lang="en-US" sz="1200" dirty="0"/>
-          </a:p>
-        </p:txBody>
-      </p:sp>
-      <p:sp>
-        <p:nvSpPr>
-          <p:cNvPr id="3" name="Punkte"/>
-          <p:cNvSpPr/>
-          <p:nvPr/>
-        </p:nvSpPr>
-        <p:spPr>
-          <a:xfrm>
-            <a:off x="9994392" y="457200"/>
-            <a:ext cx="1554480" cy="457200"/>
-          </a:xfrm>
-          <a:prstGeom prst="roundRect">
-            <a:avLst>
-              <a:gd name="adj" fmla="val 50000"/>
-            </a:avLst>
-          </a:prstGeom>
-          <a:solidFill>
-            <a:schemeClr val="accent1"/>
-          </a:solidFill>
-          <a:ln/>
-        </p:spPr>
-        <p:txBody>
-          <a:bodyPr wrap="square" lIns="0" tIns="0" rIns="0" bIns="0" rtlCol="0" anchor="ctr"/>
-          <a:lstStyle/>
-          <a:p>
-            <a:pPr marL="0" indent="0" algn="ctr">
-              <a:buNone/>
-            </a:pPr>
-            <a:r>
-              <a:rPr lang="en-US" sz="1600" b="1" dirty="0">
-                <a:solidFill>
-                  <a:srgbClr val="FFFFFF"/>
-                </a:solidFill>
-                <a:latin typeface="Calibri" pitchFamily="34" charset="0"/>
-                <a:ea typeface="Calibri" pitchFamily="34" charset="-122"/>
-                <a:cs typeface="Calibri" pitchFamily="34" charset="-120"/>
-              </a:rPr>
-              <a:t>5 Punkte</a:t>
-            </a:r>
-            <a:endParaRPr lang="en-US" sz="1600" dirty="0"/>
           </a:p>
         </p:txBody>
       </p:sp>
@@ -12396,7 +11116,7 @@
           </a:prstGeom>
           <a:extLst>
             <a:ext uri="{C572A759-6A51-4108-AA02-DFA0A04FC94B}">
-              <ma14:wrappingTextBoxFlag xmlns:ma14="http://schemas.microsoft.com/office/mac/drawingml/2011/main" xmlns="" val="0"/>
+              <ma14:wrappingTextBoxFlag xmlns="" xmlns:ma14="http://schemas.microsoft.com/office/mac/drawingml/2011/main" val="0"/>
             </a:ext>
           </a:extLst>
         </p:spPr>
@@ -12424,6 +11144,36 @@
           </a:p>
         </p:txBody>
       </p:sp>
+      <p:pic>
+        <p:nvPicPr>
+          <p:cNvPr id="9" name="Grafik 8">
+            <a:extLst>
+              <a:ext uri="{FF2B5EF4-FFF2-40B4-BE49-F238E27FC236}">
+                <a16:creationId xmlns:a16="http://schemas.microsoft.com/office/drawing/2014/main" id="{8BFD1305-3E00-7DE9-5858-8522511B2C01}"/>
+              </a:ext>
+            </a:extLst>
+          </p:cNvPr>
+          <p:cNvPicPr>
+            <a:picLocks noChangeAspect="1"/>
+          </p:cNvPicPr>
+          <p:nvPr/>
+        </p:nvPicPr>
+        <p:blipFill>
+          <a:blip r:embed="rId3"/>
+          <a:stretch>
+            <a:fillRect/>
+          </a:stretch>
+        </p:blipFill>
+        <p:spPr>
+          <a:xfrm>
+            <a:off x="480786" y="5989320"/>
+            <a:ext cx="4470400" cy="698500"/>
+          </a:xfrm>
+          <a:prstGeom prst="rect">
+            <a:avLst/>
+          </a:prstGeom>
+        </p:spPr>
+      </p:pic>
     </p:spTree>
   </p:cSld>
   <p:clrMapOvr>
@@ -12490,49 +11240,6 @@
       </p:sp>
       <p:sp>
         <p:nvSpPr>
-          <p:cNvPr id="3" name="Punkte"/>
-          <p:cNvSpPr/>
-          <p:nvPr/>
-        </p:nvSpPr>
-        <p:spPr>
-          <a:xfrm>
-            <a:off x="9994392" y="457200"/>
-            <a:ext cx="1554480" cy="457200"/>
-          </a:xfrm>
-          <a:prstGeom prst="roundRect">
-            <a:avLst>
-              <a:gd name="adj" fmla="val 50000"/>
-            </a:avLst>
-          </a:prstGeom>
-          <a:solidFill>
-            <a:schemeClr val="accent2"/>
-          </a:solidFill>
-          <a:ln/>
-        </p:spPr>
-        <p:txBody>
-          <a:bodyPr wrap="square" lIns="0" tIns="0" rIns="0" bIns="0" rtlCol="0" anchor="ctr"/>
-          <a:lstStyle/>
-          <a:p>
-            <a:pPr marL="0" indent="0" algn="ctr">
-              <a:buNone/>
-            </a:pPr>
-            <a:r>
-              <a:rPr lang="en-US" sz="1600" b="1" dirty="0">
-                <a:solidFill>
-                  <a:schemeClr val="tx1"/>
-                </a:solidFill>
-                <a:latin typeface="Calibri" pitchFamily="34" charset="0"/>
-                <a:ea typeface="Calibri" pitchFamily="34" charset="-122"/>
-                <a:cs typeface="Calibri" pitchFamily="34" charset="-120"/>
-              </a:rPr>
-              <a:t>5 Punkte</a:t>
-            </a:r>
-            <a:endParaRPr lang="en-US" sz="1600" dirty="0"/>
-          </a:p>
-        </p:txBody>
-      </p:sp>
-      <p:sp>
-        <p:nvSpPr>
           <p:cNvPr id="4" name="Kriterium"/>
           <p:cNvSpPr txBox="1"/>
           <p:nvPr/>
@@ -13312,7 +12019,7 @@
           </a:prstGeom>
           <a:extLst>
             <a:ext uri="{C572A759-6A51-4108-AA02-DFA0A04FC94B}">
-              <ma14:wrappingTextBoxFlag xmlns:ma14="http://schemas.microsoft.com/office/mac/drawingml/2011/main" xmlns="" val="0"/>
+              <ma14:wrappingTextBoxFlag xmlns="" xmlns:ma14="http://schemas.microsoft.com/office/mac/drawingml/2011/main" val="0"/>
             </a:ext>
           </a:extLst>
         </p:spPr>
@@ -13340,6 +12047,36 @@
           </a:p>
         </p:txBody>
       </p:sp>
+      <p:pic>
+        <p:nvPicPr>
+          <p:cNvPr id="24" name="Grafik 23">
+            <a:extLst>
+              <a:ext uri="{FF2B5EF4-FFF2-40B4-BE49-F238E27FC236}">
+                <a16:creationId xmlns:a16="http://schemas.microsoft.com/office/drawing/2014/main" id="{2EA0B00A-08B8-078F-142C-A6A27F5AA9A2}"/>
+              </a:ext>
+            </a:extLst>
+          </p:cNvPr>
+          <p:cNvPicPr>
+            <a:picLocks noChangeAspect="1"/>
+          </p:cNvPicPr>
+          <p:nvPr/>
+        </p:nvPicPr>
+        <p:blipFill>
+          <a:blip r:embed="rId4"/>
+          <a:stretch>
+            <a:fillRect/>
+          </a:stretch>
+        </p:blipFill>
+        <p:spPr>
+          <a:xfrm>
+            <a:off x="219529" y="6142990"/>
+            <a:ext cx="4470400" cy="698500"/>
+          </a:xfrm>
+          <a:prstGeom prst="rect">
+            <a:avLst/>
+          </a:prstGeom>
+        </p:spPr>
+      </p:pic>
     </p:spTree>
   </p:cSld>
   <p:clrMapOvr>
@@ -13401,49 +12138,6 @@
               <a:t>KRITERIUM 3 · NIST-KRITERIEN (SP 800-145)</a:t>
             </a:r>
             <a:endParaRPr lang="en-US" sz="1200" dirty="0"/>
-          </a:p>
-        </p:txBody>
-      </p:sp>
-      <p:sp>
-        <p:nvSpPr>
-          <p:cNvPr id="3" name="Punkte"/>
-          <p:cNvSpPr/>
-          <p:nvPr/>
-        </p:nvSpPr>
-        <p:spPr>
-          <a:xfrm>
-            <a:off x="9994392" y="457200"/>
-            <a:ext cx="1554480" cy="457200"/>
-          </a:xfrm>
-          <a:prstGeom prst="roundRect">
-            <a:avLst>
-              <a:gd name="adj" fmla="val 50000"/>
-            </a:avLst>
-          </a:prstGeom>
-          <a:solidFill>
-            <a:schemeClr val="accent1"/>
-          </a:solidFill>
-          <a:ln/>
-        </p:spPr>
-        <p:txBody>
-          <a:bodyPr wrap="square" lIns="0" tIns="0" rIns="0" bIns="0" rtlCol="0" anchor="ctr"/>
-          <a:lstStyle/>
-          <a:p>
-            <a:pPr marL="0" indent="0" algn="ctr">
-              <a:buNone/>
-            </a:pPr>
-            <a:r>
-              <a:rPr lang="en-US" sz="1600" b="1" dirty="0">
-                <a:solidFill>
-                  <a:srgbClr val="FFFFFF"/>
-                </a:solidFill>
-                <a:latin typeface="Calibri" pitchFamily="34" charset="0"/>
-                <a:ea typeface="Calibri" pitchFamily="34" charset="-122"/>
-                <a:cs typeface="Calibri" pitchFamily="34" charset="-120"/>
-              </a:rPr>
-              <a:t>5 Punkte</a:t>
-            </a:r>
-            <a:endParaRPr lang="en-US" sz="1600" dirty="0"/>
           </a:p>
         </p:txBody>
       </p:sp>
@@ -14864,7 +13558,7 @@
           </a:prstGeom>
           <a:extLst>
             <a:ext uri="{C572A759-6A51-4108-AA02-DFA0A04FC94B}">
-              <ma14:wrappingTextBoxFlag xmlns:ma14="http://schemas.microsoft.com/office/mac/drawingml/2011/main" xmlns="" val="0"/>
+              <ma14:wrappingTextBoxFlag xmlns="" xmlns:ma14="http://schemas.microsoft.com/office/mac/drawingml/2011/main" val="0"/>
             </a:ext>
           </a:extLst>
         </p:spPr>
@@ -14892,6 +13586,36 @@
           </a:p>
         </p:txBody>
       </p:sp>
+      <p:pic>
+        <p:nvPicPr>
+          <p:cNvPr id="7" name="Grafik 6">
+            <a:extLst>
+              <a:ext uri="{FF2B5EF4-FFF2-40B4-BE49-F238E27FC236}">
+                <a16:creationId xmlns:a16="http://schemas.microsoft.com/office/drawing/2014/main" id="{4440E93E-6CC7-694E-2069-C8491488D5B0}"/>
+              </a:ext>
+            </a:extLst>
+          </p:cNvPr>
+          <p:cNvPicPr>
+            <a:picLocks noChangeAspect="1"/>
+          </p:cNvPicPr>
+          <p:nvPr/>
+        </p:nvPicPr>
+        <p:blipFill>
+          <a:blip r:embed="rId3"/>
+          <a:stretch>
+            <a:fillRect/>
+          </a:stretch>
+        </p:blipFill>
+        <p:spPr>
+          <a:xfrm>
+            <a:off x="453136" y="5897880"/>
+            <a:ext cx="4470400" cy="698500"/>
+          </a:xfrm>
+          <a:prstGeom prst="rect">
+            <a:avLst/>
+          </a:prstGeom>
+        </p:spPr>
+      </p:pic>
     </p:spTree>
   </p:cSld>
   <p:clrMapOvr>
@@ -14958,49 +13682,6 @@
       </p:sp>
       <p:sp>
         <p:nvSpPr>
-          <p:cNvPr id="3" name="Punkte"/>
-          <p:cNvSpPr/>
-          <p:nvPr/>
-        </p:nvSpPr>
-        <p:spPr>
-          <a:xfrm>
-            <a:off x="9994392" y="457200"/>
-            <a:ext cx="1554480" cy="457200"/>
-          </a:xfrm>
-          <a:prstGeom prst="roundRect">
-            <a:avLst>
-              <a:gd name="adj" fmla="val 50000"/>
-            </a:avLst>
-          </a:prstGeom>
-          <a:solidFill>
-            <a:schemeClr val="accent1"/>
-          </a:solidFill>
-          <a:ln/>
-        </p:spPr>
-        <p:txBody>
-          <a:bodyPr wrap="square" lIns="0" tIns="0" rIns="0" bIns="0" rtlCol="0" anchor="ctr"/>
-          <a:lstStyle/>
-          <a:p>
-            <a:pPr marL="0" indent="0" algn="ctr">
-              <a:buNone/>
-            </a:pPr>
-            <a:r>
-              <a:rPr lang="en-US" sz="1600" b="1" dirty="0">
-                <a:solidFill>
-                  <a:srgbClr val="FFFFFF"/>
-                </a:solidFill>
-                <a:latin typeface="Calibri" pitchFamily="34" charset="0"/>
-                <a:ea typeface="Calibri" pitchFamily="34" charset="-122"/>
-                <a:cs typeface="Calibri" pitchFamily="34" charset="-120"/>
-              </a:rPr>
-              <a:t>5 Punkte</a:t>
-            </a:r>
-            <a:endParaRPr lang="en-US" sz="1600" dirty="0"/>
-          </a:p>
-        </p:txBody>
-      </p:sp>
-      <p:sp>
-        <p:nvSpPr>
           <p:cNvPr id="4" name="Kriterium"/>
           <p:cNvSpPr txBox="1"/>
           <p:nvPr/>
@@ -15916,7 +14597,7 @@
           </a:prstGeom>
           <a:extLst>
             <a:ext uri="{C572A759-6A51-4108-AA02-DFA0A04FC94B}">
-              <ma14:wrappingTextBoxFlag xmlns:ma14="http://schemas.microsoft.com/office/mac/drawingml/2011/main" xmlns="" val="0"/>
+              <ma14:wrappingTextBoxFlag xmlns="" xmlns:ma14="http://schemas.microsoft.com/office/mac/drawingml/2011/main" val="0"/>
             </a:ext>
           </a:extLst>
         </p:spPr>
@@ -15944,6 +14625,36 @@
           </a:p>
         </p:txBody>
       </p:sp>
+      <p:pic>
+        <p:nvPicPr>
+          <p:cNvPr id="26" name="Grafik 25">
+            <a:extLst>
+              <a:ext uri="{FF2B5EF4-FFF2-40B4-BE49-F238E27FC236}">
+                <a16:creationId xmlns:a16="http://schemas.microsoft.com/office/drawing/2014/main" id="{732B3586-53A1-51EE-9821-07A529324253}"/>
+              </a:ext>
+            </a:extLst>
+          </p:cNvPr>
+          <p:cNvPicPr>
+            <a:picLocks noChangeAspect="1"/>
+          </p:cNvPicPr>
+          <p:nvPr/>
+        </p:nvPicPr>
+        <p:blipFill>
+          <a:blip r:embed="rId3"/>
+          <a:stretch>
+            <a:fillRect/>
+          </a:stretch>
+        </p:blipFill>
+        <p:spPr>
+          <a:xfrm>
+            <a:off x="480786" y="5989320"/>
+            <a:ext cx="4470400" cy="698500"/>
+          </a:xfrm>
+          <a:prstGeom prst="rect">
+            <a:avLst/>
+          </a:prstGeom>
+        </p:spPr>
+      </p:pic>
     </p:spTree>
   </p:cSld>
   <p:clrMapOvr>
@@ -16010,49 +14721,6 @@
       </p:sp>
       <p:sp>
         <p:nvSpPr>
-          <p:cNvPr id="3" name="Punkte"/>
-          <p:cNvSpPr/>
-          <p:nvPr/>
-        </p:nvSpPr>
-        <p:spPr>
-          <a:xfrm>
-            <a:off x="9994392" y="457200"/>
-            <a:ext cx="1554480" cy="457200"/>
-          </a:xfrm>
-          <a:prstGeom prst="roundRect">
-            <a:avLst>
-              <a:gd name="adj" fmla="val 50000"/>
-            </a:avLst>
-          </a:prstGeom>
-          <a:solidFill>
-            <a:schemeClr val="accent1"/>
-          </a:solidFill>
-          <a:ln/>
-        </p:spPr>
-        <p:txBody>
-          <a:bodyPr wrap="square" lIns="0" tIns="0" rIns="0" bIns="0" rtlCol="0" anchor="ctr"/>
-          <a:lstStyle/>
-          <a:p>
-            <a:pPr marL="0" indent="0" algn="ctr">
-              <a:buNone/>
-            </a:pPr>
-            <a:r>
-              <a:rPr lang="en-US" sz="1600" b="1" dirty="0">
-                <a:solidFill>
-                  <a:srgbClr val="FFFFFF"/>
-                </a:solidFill>
-                <a:latin typeface="Calibri" pitchFamily="34" charset="0"/>
-                <a:ea typeface="Calibri" pitchFamily="34" charset="-122"/>
-                <a:cs typeface="Calibri" pitchFamily="34" charset="-120"/>
-              </a:rPr>
-              <a:t>5 Punkte</a:t>
-            </a:r>
-            <a:endParaRPr lang="en-US" sz="1600" dirty="0"/>
-          </a:p>
-        </p:txBody>
-      </p:sp>
-      <p:sp>
-        <p:nvSpPr>
           <p:cNvPr id="4" name="Kriterium"/>
           <p:cNvSpPr txBox="1"/>
           <p:nvPr/>
@@ -16958,7 +15626,7 @@
           </a:prstGeom>
           <a:extLst>
             <a:ext uri="{C572A759-6A51-4108-AA02-DFA0A04FC94B}">
-              <ma14:wrappingTextBoxFlag xmlns:ma14="http://schemas.microsoft.com/office/mac/drawingml/2011/main" xmlns="" val="0"/>
+              <ma14:wrappingTextBoxFlag xmlns="" xmlns:ma14="http://schemas.microsoft.com/office/mac/drawingml/2011/main" val="0"/>
             </a:ext>
           </a:extLst>
         </p:spPr>
@@ -16986,6 +15654,36 @@
           </a:p>
         </p:txBody>
       </p:sp>
+      <p:pic>
+        <p:nvPicPr>
+          <p:cNvPr id="23" name="Grafik 22">
+            <a:extLst>
+              <a:ext uri="{FF2B5EF4-FFF2-40B4-BE49-F238E27FC236}">
+                <a16:creationId xmlns:a16="http://schemas.microsoft.com/office/drawing/2014/main" id="{25A3BD74-BDB2-BA78-48A7-4C0727D5A1C6}"/>
+              </a:ext>
+            </a:extLst>
+          </p:cNvPr>
+          <p:cNvPicPr>
+            <a:picLocks noChangeAspect="1"/>
+          </p:cNvPicPr>
+          <p:nvPr/>
+        </p:nvPicPr>
+        <p:blipFill>
+          <a:blip r:embed="rId6"/>
+          <a:stretch>
+            <a:fillRect/>
+          </a:stretch>
+        </p:blipFill>
+        <p:spPr>
+          <a:xfrm>
+            <a:off x="480786" y="5989320"/>
+            <a:ext cx="4470400" cy="698500"/>
+          </a:xfrm>
+          <a:prstGeom prst="rect">
+            <a:avLst/>
+          </a:prstGeom>
+        </p:spPr>
+      </p:pic>
     </p:spTree>
   </p:cSld>
   <p:clrMapOvr>

</xml_diff>

<commit_message>
Cloud-Praesentation: Sensor-Drift auf UMGESETZT, Redemanuskripte auf aktuellen Stand (Broker-Auth geloest, Drift-Skript mit Berliner Zeit)
Co-Authored-By: Claude Sonnet 5.5 <noreply@anthropic.com>
Claude-Session: https://claude.ai/code/session_01DAyhZuQPfkaakwWeF4BFCC
</commit_message>
<xml_diff>
--- a/Challenge-III-Ice-Truck-Cloud/Praesentation/ice-truck-in-der-cloud.pptx
+++ b/Challenge-III-Ice-Truck-Cloud/Praesentation/ice-truck-in-der-cloud.pptx
@@ -502,7 +502,7 @@
           <a:p>
             <a:r>
               <a:rPr lang="en-US" dirty="0"/>
-              <a:t>SPRECHER: Felix · RICHTZEIT: 1:30 min — Hier zeigen wir die Ergebnisse. LIVE-DEMO oder Screenshot: ThingSpeak-Kanal mit Temperaturverlauf, Lüfter und Ventil. Die Messung läuft alle 5 Sekunden. Der Upload wird wegen der Free-Grenze alle 15 Sekunden gebündelt, jede Messung behält ihre eigene Uhrzeit. Es gibt 8 Felder, und der CSV-Export dient als Nachweis für Kontrollen. Der Kanal ist öffentlich, deshalb kann jeder ohne Anmeldung zuschauen. VOR DEM VORTRAG: Den Platzhalter durch einen echten Screenshot ersetzen und prüfen, dass die Punkte im 5-Sekunden-Abstand ankommen. ÜBERGABE: Weiter mit den Zusatzfunktionen (Felix bleibt).</a:t>
+              <a:t>SPRECHER: Felix · RICHTZEIT: 1:30 min — Hier zeigen wir die Ergebnisse. LIVE-DEMO oder Screenshot: ThingSpeak-Kanal mit Temperaturverlauf, Lüfter und Ventil. Die Messung läuft alle 5 Sekunden. Der Upload wird wegen der Free-Grenze alle 15 Sekunden gebündelt, jede Messung behält ihre eigene Uhrzeit. Es gibt 8 Felder, und der CSV-Export dient als Nachweis für Kontrollen. Der Kanal ist öffentlich, deshalb kann jeder ohne Anmeldung zuschauen. VOR DEM VORTRAG: Pi vorher durchlaufen lassen und prüfen, dass die Punkte im 5-Sekunden-Abstand ankommen. ÜBERGABE: Weiter mit den Zusatzfunktionen (Felix bleibt).</a:t>
             </a:r>
           </a:p>
         </p:txBody>
@@ -589,7 +589,7 @@
           <a:p>
             <a:r>
               <a:rPr lang="en-US" dirty="0"/>
-              <a:t>SPRECHER: Felix · RICHTZEIT: 1:00 min — Store and Forward: Bei einem Funkloch werden fehlende Messungen später mit ihrer Originalzeit nachgeliefert. Health-Flags: Die Bridge warnt schon am Truck bei zu hoher Temperatur, abweichenden Sensoren oder einem eingefrorenen Sensor. Alarm: Sobald Field 3 über 30 Grad steigt, startet ThingSpeak React eine MATLAB-Analyse, die eine Nachricht an unseren Discord-Server und eine E-Mail schickt. Die Zugangsdaten liegen nur in ThingSpeak. Laut My Account sind 800 Alarm-Mails im Jahr erlaubt. Als Nächstes das Sensor-Drift-Diagramm als Beispiel für Predictive Maintenance. VOR DEM VORTRAG: Wenn das Diagramm läuft, die Karte auf UMGESETZT setzen, sonst die Karte löschen. ÜBERGABE: Weiter mit dem Fazit (Felix bleibt).</a:t>
+              <a:t>SPRECHER: Felix · RICHTZEIT: 1:00 min — Store and Forward: Bei einem Funkloch werden fehlende Messungen später mit ihrer Originalzeit nachgeliefert. Health-Flags: Die Bridge warnt schon am Truck bei zu hoher Temperatur, abweichenden Sensoren oder einem eingefrorenen Sensor. Alarm: Sobald Field 3 über 30 Grad steigt, startet ThingSpeak React eine MATLAB-Analyse, die eine Nachricht an unseren Discord-Server und eine E-Mail schickt. Die Zugangsdaten liegen nur in ThingSpeak. Laut My Account sind 800 Alarm-Mails im Jahr erlaubt. Sensor-Drift: Ein MATLAB-Diagramm in ThingSpeak zeigt pro Minute, wie weit die beiden Temperatursensoren auseinanderliegen, mit gleitendem Mittelwert und Warnschwelle bei 3 Grad. Wächst die Abweichung stetig, deutet das auf einen defekten Sensor oder Wackelkontakt hin, und die Wartung lässt sich planen, bevor der Truck ausfällt. VOR DEM VORTRAG: Pi vorher durchlaufen lassen, damit das Diagramm frische Minutenwerte zeigt. ÜBERGABE: Weiter mit dem Fazit (Felix bleibt).</a:t>
             </a:r>
           </a:p>
         </p:txBody>
@@ -676,7 +676,7 @@
           <a:p>
             <a:r>
               <a:rPr lang="en-US" dirty="0"/>
-              <a:t>SPRECHER: Felix · RICHTZEIT: 1:00 min — Wir erfüllen die Nachweispflicht deutlich besser: Die Daten kommen automatisch und zeitnah in die Cloud und sind von überall abrufbar. Sie sind doppelt gesichert, lokal im Pi und in der Cloud. Ausblick: Für den echten Flottenbetrieb würden wir Azure IoT Hub mit EU-Region wählen, die Alarme ausbauen und die Sensor-Drift für Predictive Maintenance nutzen. Gelernt: Unsere Bridge trennt Logik und Sender, der Anbieter lässt sich austauschen. ThingSpeak jetzt, Azure für die Flotte. Vielen Dank, wir freuen uns auf eure Fragen. ÜBERGABE: Fragen beantwortet, wer fachlich dran ist (siehe Rückfragen im Redemanuskript).</a:t>
+              <a:t>SPRECHER: Felix · RICHTZEIT: 1:00 min — Wir erfüllen die Nachweispflicht deutlich besser: Die Daten kommen automatisch und zeitnah in die Cloud und sind von überall abrufbar. Sie sind doppelt gesichert, lokal im Pi und in der Cloud. Ausblick: Für den echten Flottenbetrieb würden wir Azure IoT Hub mit EU-Region wählen, die Alarme ausbauen und die Sensor-Drift-Auswertung zur Wartungsplanung der ganzen Flotte nutzen. Gelernt: Unsere Bridge trennt Logik und Sender, der Anbieter lässt sich austauschen. ThingSpeak jetzt, Azure für die Flotte. Vielen Dank, wir freuen uns auf eure Fragen. ÜBERGABE: Fragen beantwortet, wer fachlich dran ist (siehe Rückfragen im Redemanuskript).</a:t>
             </a:r>
           </a:p>
         </p:txBody>
@@ -5227,7 +5227,7 @@
         <p:spPr>
           <a:xfrm>
             <a:off x="6519672" y="4206240"/>
-            <a:ext cx="1188720" cy="310896"/>
+            <a:ext cx="1371600" cy="310896"/>
           </a:xfrm>
           <a:prstGeom prst="roundRect">
             <a:avLst>
@@ -5235,7 +5235,7 @@
             </a:avLst>
           </a:prstGeom>
           <a:solidFill>
-            <a:srgbClr val="FDE9CF"/>
+            <a:srgbClr val="D9F2E3"/>
           </a:solidFill>
           <a:ln/>
         </p:spPr>
@@ -5249,13 +5249,13 @@
             <a:r>
               <a:rPr lang="en-US" sz="1200" b="1" dirty="0">
                 <a:solidFill>
-                  <a:srgbClr val="8A4B05"/>
+                  <a:srgbClr val="1B6B3A"/>
                 </a:solidFill>
                 <a:latin typeface="Calibri" pitchFamily="34" charset="0"/>
                 <a:ea typeface="Calibri" pitchFamily="34" charset="-122"/>
                 <a:cs typeface="Calibri" pitchFamily="34" charset="-120"/>
               </a:rPr>
-              <a:t>IN ARBEIT</a:t>
+              <a:t>UMGESETZT</a:t>
             </a:r>
             <a:endParaRPr lang="en-US" sz="1200" dirty="0"/>
           </a:p>
@@ -5333,7 +5333,7 @@
                 <a:ea typeface="Calibri" pitchFamily="34" charset="-122"/>
                 <a:cs typeface="Calibri" pitchFamily="34" charset="-120"/>
               </a:rPr>
-              <a:t>MATLAB-Diagramm: Wandert ein Sensor vom anderen weg? So lässt sich Wartung planen.</a:t>
+              <a:t>MATLAB-Diagramm: Wandert ein Sensor vom anderen weg? Abweichung pro Minute, Warnschwelle 3 °C.</a:t>
             </a:r>
             <a:endParaRPr lang="en-US" sz="1500" dirty="0"/>
           </a:p>

</xml_diff>

<commit_message>
Cloud-Praesentation Folie 11: Upload im Minutentakt statt 15-s-Takt
Co-Authored-By: Claude Sonnet 5.5 <noreply@anthropic.com>
Claude-Session: https://claude.ai/code/session_01DAyhZuQPfkaakwWeF4BFCC
</commit_message>
<xml_diff>
--- a/Challenge-III-Ice-Truck-Cloud/Praesentation/ice-truck-in-der-cloud.pptx
+++ b/Challenge-III-Ice-Truck-Cloud/Praesentation/ice-truck-in-der-cloud.pptx
@@ -502,7 +502,7 @@
           <a:p>
             <a:r>
               <a:rPr lang="en-US" dirty="0"/>
-              <a:t>SPRECHER: Felix · RICHTZEIT: 1:30 min — Hier zeigen wir die Ergebnisse. LIVE-DEMO oder Screenshot: ThingSpeak-Kanal mit Temperaturverlauf, Lüfter und Ventil. Die Messung läuft alle 5 Sekunden. Der Upload wird wegen der Free-Grenze alle 15 Sekunden gebündelt, jede Messung behält ihre eigene Uhrzeit. Es gibt 8 Felder, und der CSV-Export dient als Nachweis für Kontrollen. Der Kanal ist öffentlich, deshalb kann jeder ohne Anmeldung zuschauen. VOR DEM VORTRAG: Pi vorher durchlaufen lassen und prüfen, dass die Punkte im 5-Sekunden-Abstand ankommen. ÜBERGABE: Weiter mit den Zusatzfunktionen (Felix bleibt).</a:t>
+              <a:t>SPRECHER: Felix · RICHTZEIT: 1:30 min — Hier zeigen wir die Ergebnisse. LIVE-DEMO oder Screenshot: ThingSpeak-Kanal mit Temperaturverlauf, Lüfter und Ventil. Die Messung läuft alle 5 Sekunden. Der Upload wird gebündelt und läuft einmal pro Minute, die Free-Grenze von 15 Sekunden unterschreiten wir damit deutlich. Jede Messung behält ihre eigene Uhrzeit, das Diagramm zeigt also trotzdem das 5-Sekunden-Raster. Die Diagramme in ThingSpeak aktualisieren sich im Minutentakt. Es gibt 8 Felder, und der CSV-Export dient als Nachweis für Kontrollen. Der Kanal ist öffentlich, deshalb kann jeder ohne Anmeldung zuschauen. VOR DEM VORTRAG: Pi vorher durchlaufen lassen und prüfen, dass die Punkte im 5-Sekunden-Abstand ankommen. ÜBERGABE: Weiter mit den Zusatzfunktionen (Felix bleibt).</a:t>
             </a:r>
           </a:p>
         </p:txBody>
@@ -4174,7 +4174,7 @@
                 <a:ea typeface="Calibri" pitchFamily="34" charset="-122"/>
                 <a:cs typeface="Calibri" pitchFamily="34" charset="-120"/>
               </a:rPr>
-              <a:t>Messung alle 5 s, Upload gebündelt im 15-s-Takt</a:t>
+              <a:t>Messung alle 5 s, Upload gebündelt einmal pro Minute</a:t>
             </a:r>
             <a:endParaRPr lang="en-US" sz="1600" dirty="0"/>
           </a:p>

</xml_diff>

<commit_message>
Cloud-Praesentation: Werte alle 5 s, Diagramm im Minutentakt; Health-Flags umbenannt in Warnmarker im Datensatz
Co-Authored-By: Claude Sonnet 5.5 <noreply@anthropic.com>
Claude-Session: https://claude.ai/code/session_01DAyhZuQPfkaakwWeF4BFCC
</commit_message>
<xml_diff>
--- a/Challenge-III-Ice-Truck-Cloud/Praesentation/ice-truck-in-der-cloud.pptx
+++ b/Challenge-III-Ice-Truck-Cloud/Praesentation/ice-truck-in-der-cloud.pptx
@@ -502,7 +502,7 @@
           <a:p>
             <a:r>
               <a:rPr lang="en-US" dirty="0"/>
-              <a:t>SPRECHER: Felix · RICHTZEIT: 1:30 min — Hier zeigen wir die Ergebnisse. LIVE-DEMO oder Screenshot: ThingSpeak-Kanal mit Temperaturverlauf, Lüfter und Ventil. Die Messung läuft alle 5 Sekunden. Der Upload wird gebündelt und läuft einmal pro Minute, die Free-Grenze von 15 Sekunden unterschreiten wir damit deutlich. Jede Messung behält ihre eigene Uhrzeit, das Diagramm zeigt also trotzdem das 5-Sekunden-Raster. Die Diagramme in ThingSpeak aktualisieren sich im Minutentakt. Es gibt 8 Felder, und der CSV-Export dient als Nachweis für Kontrollen. Der Kanal ist öffentlich, deshalb kann jeder ohne Anmeldung zuschauen. VOR DEM VORTRAG: Pi vorher durchlaufen lassen und prüfen, dass die Punkte im 5-Sekunden-Abstand ankommen. ÜBERGABE: Weiter mit den Zusatzfunktionen (Felix bleibt).</a:t>
+              <a:t>SPRECHER: Felix · RICHTZEIT: 1:30 min — Hier zeigen wir die Ergebnisse. LIVE-DEMO oder Screenshot: ThingSpeak-Kanal mit Temperaturverlauf, Lüfter und Ventil. Die Werte kommen alle 5 Sekunden, jeder Punkt im Diagramm ist eine Messung. Hochgeladen wird gebündelt einmal pro Minute, deshalb aktualisieren sich die Diagramme in ThingSpeak im Minutentakt. Jede Messung behält ihre eigene Uhrzeit. Nach einem Funkloch die Seite neu laden, dann ist die Lücke gefüllt. Es gibt 8 Felder, und der CSV-Export dient als Nachweis für Kontrollen. Der Kanal ist öffentlich, deshalb kann jeder ohne Anmeldung zuschauen. VOR DEM VORTRAG: Pi vorher durchlaufen lassen und prüfen, dass die Punkte im 5-Sekunden-Abstand ankommen. ÜBERGABE: Weiter mit den Zusatzfunktionen (Felix bleibt).</a:t>
             </a:r>
           </a:p>
         </p:txBody>
@@ -589,7 +589,7 @@
           <a:p>
             <a:r>
               <a:rPr lang="en-US" dirty="0"/>
-              <a:t>SPRECHER: Felix · RICHTZEIT: 1:00 min — Store and Forward: Bei einem Funkloch werden fehlende Messungen später mit ihrer Originalzeit nachgeliefert. Health-Flags: Die Bridge warnt schon am Truck bei zu hoher Temperatur, abweichenden Sensoren oder einem eingefrorenen Sensor. Alarm: Sobald Field 3 über 30 Grad steigt, startet ThingSpeak React eine MATLAB-Analyse, die eine Nachricht an unseren Discord-Server und eine E-Mail schickt. Die Zugangsdaten liegen nur in ThingSpeak. Laut My Account sind 800 Alarm-Mails im Jahr erlaubt. Sensor-Drift: Ein MATLAB-Diagramm in ThingSpeak zeigt pro Minute, wie weit die beiden Temperatursensoren auseinanderliegen, mit gleitendem Mittelwert und Warnschwelle bei 3 Grad. Wächst die Abweichung stetig, deutet das auf einen defekten Sensor oder Wackelkontakt hin, und die Wartung lässt sich planen, bevor der Truck ausfällt. VOR DEM VORTRAG: Pi vorher durchlaufen lassen, damit das Diagramm frische Minutenwerte zeigt. ÜBERGABE: Weiter mit dem Fazit (Felix bleibt).</a:t>
+              <a:t>SPRECHER: Felix · RICHTZEIT: 1:00 min — Store and Forward: Bei einem Funkloch werden fehlende Messungen später mit ihrer Originalzeit nachgeliefert. Warnmarker im Datensatz: Der Pi prüft jedes Minutenpaket und vermerkt zu hohe Temperatur, abweichende oder eingefrorene Sensoren im Statusfeld, sichtbar im CSV-Export. Der Alarm per Discord und Mail hängt nicht daran, sondern an Field 3. Alarm: Sobald Field 3 über 30 Grad steigt, startet ThingSpeak React eine MATLAB-Analyse, die eine Nachricht an unseren Discord-Server und eine E-Mail schickt. Die Zugangsdaten liegen nur in ThingSpeak. Laut My Account sind 800 Alarm-Mails im Jahr erlaubt. Sensor-Drift: Ein MATLAB-Diagramm in ThingSpeak zeigt pro Minute, wie weit die beiden Temperatursensoren auseinanderliegen, mit gleitendem Mittelwert und Warnschwelle bei 3 Grad. Wächst die Abweichung stetig, deutet das auf einen defekten Sensor oder Wackelkontakt hin, und die Wartung lässt sich planen, bevor der Truck ausfällt. VOR DEM VORTRAG: Pi vorher durchlaufen lassen, damit das Diagramm frische Minutenwerte zeigt. ÜBERGABE: Weiter mit dem Fazit (Felix bleibt).</a:t>
             </a:r>
           </a:p>
         </p:txBody>
@@ -4174,7 +4174,7 @@
                 <a:ea typeface="Calibri" pitchFamily="34" charset="-122"/>
                 <a:cs typeface="Calibri" pitchFamily="34" charset="-120"/>
               </a:rPr>
-              <a:t>Messung alle 5 s, Upload gebündelt einmal pro Minute</a:t>
+              <a:t>Werte alle 5 s, Diagramm aktualisiert sich jede Minute</a:t>
             </a:r>
             <a:endParaRPr lang="en-US" sz="1600" dirty="0"/>
           </a:p>
@@ -4984,7 +4984,7 @@
                 <a:ea typeface="Calibri" pitchFamily="34" charset="-122"/>
                 <a:cs typeface="Calibri" pitchFamily="34" charset="-120"/>
               </a:rPr>
-              <a:t>Health-Flags am Edge</a:t>
+              <a:t>Warnmarker im Datensatz</a:t>
             </a:r>
             <a:endParaRPr lang="en-US" sz="2200" dirty="0"/>
           </a:p>
@@ -5023,7 +5023,7 @@
                 <a:ea typeface="Calibri" pitchFamily="34" charset="-122"/>
                 <a:cs typeface="Calibri" pitchFamily="34" charset="-120"/>
               </a:rPr>
-              <a:t>Warnung bei zu hoher Temperatur, abweichenden Sensoren oder eingefrorenem Sensor.</a:t>
+              <a:t>Der Pi vermerkt zu warm, abweichende oder eingefrorene Sensoren im Statusfeld, sichtbar im CSV-Export.</a:t>
             </a:r>
             <a:endParaRPr lang="en-US" sz="1500" dirty="0"/>
           </a:p>

</xml_diff>